<commit_message>
feat(slides): add Agent Studio intro slides (21-22)
Slide 21: Cloudera Agent Studio 3.0 capabilities overview —
workflow builder, tools catalog, multi-LLM support, test/deploy,
Phoenix observability, guardrails, form factors (PVC GA + Public TP).

Slide 22: Agent Studio maps to all four harness pillars —
progressive context, agent specialization, persistent memory,
structured execution — with concrete product implementations.

Source: Agent Studio Support Training.pdf, docs/studios/agent_studio.md

Co-Authored-By: Claude <noreply@anthropic.com>
</commit_message>
<xml_diff>
--- a/Cloudera_AI_Landscape.pptx
+++ b/Cloudera_AI_Landscape.pptx
@@ -25,9 +25,11 @@
     <p:sldId id="273" r:id="rId19"/>
     <p:sldId id="274" r:id="rId20"/>
     <p:sldId id="275" r:id="rId21"/>
+    <p:sldId id="276" r:id="rId22"/>
+    <p:sldId id="277" r:id="rId23"/>
   </p:sldIdLst>
   <p:notesMasterIdLst>
-    <p:notesMasterId r:id="rId22"/>
+    <p:notesMasterId r:id="rId24"/>
   </p:notesMasterIdLst>
   <p:sldSz cx="9144000" cy="5143500"/>
   <p:notesSz cx="5143500" cy="9144000"/>
@@ -1601,6 +1603,182 @@
             <a:fld id="{F7021451-1387-4CA6-816F-3879F97B5CBC}" type="slidenum">
               <a:rPr lang="en-US"/>
               <a:t>20</a:t>
+            </a:fld>
+            <a:endParaRPr lang="en-US"/>
+          </a:p>
+        </p:txBody>
+      </p:sp>
+    </p:spTree>
+    <p:extLst>
+      <p:ext uri="{BB962C8B-B14F-4D97-AF65-F5344CB8AC3E}">
+        <p14:creationId xmlns:p14="http://schemas.microsoft.com/office/powerpoint/2010/main" val="1024086991"/>
+      </p:ext>
+    </p:extLst>
+  </p:cSld>
+  <p:clrMapOvr>
+    <a:masterClrMapping/>
+  </p:clrMapOvr>
+</p:notes>
+</file>
+
+<file path=ppt/notesSlides/notesSlide21.xml><?xml version="1.0" encoding="utf-8"?>
+<p:notes xmlns:a="http://schemas.openxmlformats.org/drawingml/2006/main" xmlns:r="http://schemas.openxmlformats.org/officeDocument/2006/relationships" xmlns:p="http://schemas.openxmlformats.org/presentationml/2006/main">
+  <p:cSld>
+    <p:spTree>
+      <p:nvGrpSpPr>
+        <p:cNvPr id="1" name=""/>
+        <p:cNvGrpSpPr/>
+        <p:nvPr/>
+      </p:nvGrpSpPr>
+      <p:grpSpPr>
+        <a:xfrm>
+          <a:off x="0" y="0"/>
+          <a:ext cx="0" cy="0"/>
+          <a:chOff x="0" y="0"/>
+          <a:chExt cx="0" cy="0"/>
+        </a:xfrm>
+      </p:grpSpPr>
+      <p:sp>
+        <p:nvSpPr>
+          <p:cNvPr id="2" name="Slide Image Placeholder 1"/>
+          <p:cNvSpPr>
+            <a:spLocks noGrp="1" noRot="1" noChangeAspect="1"/>
+          </p:cNvSpPr>
+          <p:nvPr>
+            <p:ph type="sldImg"/>
+          </p:nvPr>
+        </p:nvSpPr>
+        <p:spPr/>
+      </p:sp>
+      <p:sp>
+        <p:nvSpPr>
+          <p:cNvPr id="3" name="Notes Placeholder 2"/>
+          <p:cNvSpPr>
+            <a:spLocks noGrp="1"/>
+          </p:cNvSpPr>
+          <p:nvPr>
+            <p:ph type="body" idx="1"/>
+          </p:nvPr>
+        </p:nvSpPr>
+        <p:spPr/>
+        <p:txBody>
+          <a:bodyPr/>
+          <a:lstStyle/>
+          <a:p>
+            <a:r>
+              <a:rPr lang="en-US" dirty="0"/>
+              <a:t/>
+            </a:r>
+            <a:endParaRPr lang="en-US" dirty="0"/>
+          </a:p>
+        </p:txBody>
+      </p:sp>
+      <p:sp>
+        <p:nvSpPr>
+          <p:cNvPr id="4" name="Slide Number Placeholder 3"/>
+          <p:cNvSpPr>
+            <a:spLocks noGrp="1"/>
+          </p:cNvSpPr>
+          <p:nvPr>
+            <p:ph type="sldNum" sz="quarter" idx="10"/>
+          </p:nvPr>
+        </p:nvSpPr>
+        <p:spPr/>
+        <p:txBody>
+          <a:bodyPr/>
+          <a:lstStyle/>
+          <a:p>
+            <a:fld id="{F7021451-1387-4CA6-816F-3879F97B5CBC}" type="slidenum">
+              <a:rPr lang="en-US"/>
+              <a:t>21</a:t>
+            </a:fld>
+            <a:endParaRPr lang="en-US"/>
+          </a:p>
+        </p:txBody>
+      </p:sp>
+    </p:spTree>
+    <p:extLst>
+      <p:ext uri="{BB962C8B-B14F-4D97-AF65-F5344CB8AC3E}">
+        <p14:creationId xmlns:p14="http://schemas.microsoft.com/office/powerpoint/2010/main" val="1024086991"/>
+      </p:ext>
+    </p:extLst>
+  </p:cSld>
+  <p:clrMapOvr>
+    <a:masterClrMapping/>
+  </p:clrMapOvr>
+</p:notes>
+</file>
+
+<file path=ppt/notesSlides/notesSlide22.xml><?xml version="1.0" encoding="utf-8"?>
+<p:notes xmlns:a="http://schemas.openxmlformats.org/drawingml/2006/main" xmlns:r="http://schemas.openxmlformats.org/officeDocument/2006/relationships" xmlns:p="http://schemas.openxmlformats.org/presentationml/2006/main">
+  <p:cSld>
+    <p:spTree>
+      <p:nvGrpSpPr>
+        <p:cNvPr id="1" name=""/>
+        <p:cNvGrpSpPr/>
+        <p:nvPr/>
+      </p:nvGrpSpPr>
+      <p:grpSpPr>
+        <a:xfrm>
+          <a:off x="0" y="0"/>
+          <a:ext cx="0" cy="0"/>
+          <a:chOff x="0" y="0"/>
+          <a:chExt cx="0" cy="0"/>
+        </a:xfrm>
+      </p:grpSpPr>
+      <p:sp>
+        <p:nvSpPr>
+          <p:cNvPr id="2" name="Slide Image Placeholder 1"/>
+          <p:cNvSpPr>
+            <a:spLocks noGrp="1" noRot="1" noChangeAspect="1"/>
+          </p:cNvSpPr>
+          <p:nvPr>
+            <p:ph type="sldImg"/>
+          </p:nvPr>
+        </p:nvSpPr>
+        <p:spPr/>
+      </p:sp>
+      <p:sp>
+        <p:nvSpPr>
+          <p:cNvPr id="3" name="Notes Placeholder 2"/>
+          <p:cNvSpPr>
+            <a:spLocks noGrp="1"/>
+          </p:cNvSpPr>
+          <p:nvPr>
+            <p:ph type="body" idx="1"/>
+          </p:nvPr>
+        </p:nvSpPr>
+        <p:spPr/>
+        <p:txBody>
+          <a:bodyPr/>
+          <a:lstStyle/>
+          <a:p>
+            <a:r>
+              <a:rPr lang="en-US" dirty="0"/>
+              <a:t/>
+            </a:r>
+            <a:endParaRPr lang="en-US" dirty="0"/>
+          </a:p>
+        </p:txBody>
+      </p:sp>
+      <p:sp>
+        <p:nvSpPr>
+          <p:cNvPr id="4" name="Slide Number Placeholder 3"/>
+          <p:cNvSpPr>
+            <a:spLocks noGrp="1"/>
+          </p:cNvSpPr>
+          <p:nvPr>
+            <p:ph type="sldNum" sz="quarter" idx="10"/>
+          </p:nvPr>
+        </p:nvSpPr>
+        <p:spPr/>
+        <p:txBody>
+          <a:bodyPr/>
+          <a:lstStyle/>
+          <a:p>
+            <a:fld id="{F7021451-1387-4CA6-816F-3879F97B5CBC}" type="slidenum">
+              <a:rPr lang="en-US"/>
+              <a:t>22</a:t>
             </a:fld>
             <a:endParaRPr lang="en-US"/>
           </a:p>
@@ -4221,7 +4399,7 @@
                 <a:ea typeface="Calibri" pitchFamily="34" charset="-122"/>
                 <a:cs typeface="Calibri" pitchFamily="34" charset="-120"/>
               </a:rPr>
-              <a:t>10 / 20</a:t>
+              <a:t>10 / 22</a:t>
             </a:r>
             <a:endParaRPr lang="en-US" sz="800" dirty="0"/>
           </a:p>
@@ -5283,7 +5461,7 @@
                 <a:ea typeface="Calibri" pitchFamily="34" charset="-122"/>
                 <a:cs typeface="Calibri" pitchFamily="34" charset="-120"/>
               </a:rPr>
-              <a:t>11 / 20</a:t>
+              <a:t>11 / 22</a:t>
             </a:r>
             <a:endParaRPr lang="en-US" sz="800" dirty="0"/>
           </a:p>
@@ -6825,7 +7003,7 @@
                 <a:ea typeface="Calibri" pitchFamily="34" charset="-122"/>
                 <a:cs typeface="Calibri" pitchFamily="34" charset="-120"/>
               </a:rPr>
-              <a:t>12 / 20</a:t>
+              <a:t>12 / 22</a:t>
             </a:r>
             <a:endParaRPr lang="en-US" sz="800" dirty="0"/>
           </a:p>
@@ -8346,7 +8524,7 @@
                 <a:ea typeface="Calibri" pitchFamily="34" charset="-122"/>
                 <a:cs typeface="Calibri" pitchFamily="34" charset="-120"/>
               </a:rPr>
-              <a:t>13 / 20</a:t>
+              <a:t>13 / 22</a:t>
             </a:r>
             <a:endParaRPr lang="en-US" sz="800" dirty="0"/>
           </a:p>
@@ -9453,7 +9631,7 @@
                 <a:ea typeface="Calibri" pitchFamily="34" charset="-122"/>
                 <a:cs typeface="Calibri" pitchFamily="34" charset="-120"/>
               </a:rPr>
-              <a:t>14 / 20</a:t>
+              <a:t>14 / 22</a:t>
             </a:r>
             <a:endParaRPr lang="en-US" sz="800" dirty="0"/>
           </a:p>
@@ -10207,7 +10385,7 @@
                 <a:ea typeface="Calibri" pitchFamily="34" charset="-122"/>
                 <a:cs typeface="Calibri" pitchFamily="34" charset="-120"/>
               </a:rPr>
-              <a:t>15 / 20</a:t>
+              <a:t>15 / 22</a:t>
             </a:r>
             <a:endParaRPr lang="en-US" sz="800" dirty="0"/>
           </a:p>
@@ -10937,7 +11115,7 @@
                 <a:ea typeface="Calibri" pitchFamily="34" charset="-122"/>
                 <a:cs typeface="Calibri" pitchFamily="34" charset="-120"/>
               </a:rPr>
-              <a:t>16 / 20</a:t>
+              <a:t>16 / 22</a:t>
             </a:r>
             <a:endParaRPr lang="en-US" sz="800" dirty="0"/>
           </a:p>
@@ -12427,7 +12605,7 @@
                 <a:ea typeface="Calibri" pitchFamily="34" charset="-122"/>
                 <a:cs typeface="Calibri" pitchFamily="34" charset="-120"/>
               </a:rPr>
-              <a:t>17 / 20</a:t>
+              <a:t>17 / 22</a:t>
             </a:r>
             <a:endParaRPr lang="en-US" sz="800" dirty="0"/>
           </a:p>
@@ -13846,7 +14024,7 @@
                 <a:ea typeface="Calibri" pitchFamily="34" charset="-122"/>
                 <a:cs typeface="Calibri" pitchFamily="34" charset="-120"/>
               </a:rPr>
-              <a:t>18 / 20</a:t>
+              <a:t>18 / 22</a:t>
             </a:r>
             <a:endParaRPr lang="en-US" sz="800" dirty="0"/>
           </a:p>
@@ -15288,7 +15466,7 @@
                 <a:ea typeface="Calibri" pitchFamily="34" charset="-122"/>
                 <a:cs typeface="Calibri" pitchFamily="34" charset="-120"/>
               </a:rPr>
-              <a:t>19 / 20</a:t>
+              <a:t>19 / 22</a:t>
             </a:r>
             <a:endParaRPr lang="en-US" sz="800" dirty="0"/>
           </a:p>
@@ -15970,7 +16148,7 @@
                 <a:ea typeface="Calibri" pitchFamily="34" charset="-122"/>
                 <a:cs typeface="Calibri" pitchFamily="34" charset="-120"/>
               </a:rPr>
-              <a:t>2 / 20</a:t>
+              <a:t>2 / 22</a:t>
             </a:r>
             <a:endParaRPr lang="en-US" sz="800" dirty="0"/>
           </a:p>
@@ -18314,7 +18492,3497 @@
                 <a:ea typeface="Calibri" pitchFamily="34" charset="-122"/>
                 <a:cs typeface="Calibri" pitchFamily="34" charset="-120"/>
               </a:rPr>
-              <a:t>20 / 20</a:t>
+              <a:t>20 / 22</a:t>
+            </a:r>
+            <a:endParaRPr lang="en-US" sz="800" dirty="0"/>
+          </a:p>
+        </p:txBody>
+      </p:sp>
+    </p:spTree>
+  </p:cSld>
+  <p:clrMapOvr>
+    <a:masterClrMapping/>
+  </p:clrMapOvr>
+</p:sld>
+</file>
+
+<file path=ppt/slides/slide21.xml><?xml version="1.0" encoding="utf-8"?>
+<p:sld xmlns:a="http://schemas.openxmlformats.org/drawingml/2006/main" xmlns:r="http://schemas.openxmlformats.org/officeDocument/2006/relationships" xmlns:p="http://schemas.openxmlformats.org/presentationml/2006/main">
+  <p:cSld name="Slide 21">
+    <p:bg>
+      <p:bgPr>
+        <a:solidFill>
+          <a:srgbClr val="FFFFFF"/>
+        </a:solidFill>
+      </p:bgPr>
+    </p:bg>
+    <p:spTree>
+      <p:nvGrpSpPr>
+        <p:cNvPr id="1" name=""/>
+        <p:cNvGrpSpPr/>
+        <p:nvPr/>
+      </p:nvGrpSpPr>
+      <p:grpSpPr>
+        <a:xfrm>
+          <a:off x="0" y="0"/>
+          <a:ext cx="0" cy="0"/>
+          <a:chOff x="0" y="0"/>
+          <a:chExt cx="0" cy="0"/>
+        </a:xfrm>
+      </p:grpSpPr>
+      <p:sp>
+        <p:nvSpPr>
+          <p:cNvPr id="2" name="Text 0"/>
+          <p:cNvSpPr/>
+          <p:nvPr/>
+        </p:nvSpPr>
+        <p:spPr>
+          <a:xfrm>
+            <a:off x="6858000" y="292608"/>
+            <a:ext cx="1737360" cy="292608"/>
+          </a:xfrm>
+          <a:prstGeom prst="rect">
+            <a:avLst/>
+          </a:prstGeom>
+          <a:noFill/>
+          <a:ln/>
+        </p:spPr>
+        <p:txBody>
+          <a:bodyPr wrap="square" lIns="0" tIns="0" rIns="0" bIns="0" rtlCol="0" anchor="ctr"/>
+          <a:lstStyle/>
+          <a:p>
+            <a:pPr algn="r" indent="0" marL="0">
+              <a:buNone/>
+            </a:pPr>
+            <a:r>
+              <a:rPr lang="en-US" sz="1300" b="1" spc="300" kern="0" dirty="0">
+                <a:solidFill>
+                  <a:srgbClr val="EE5A29"/>
+                </a:solidFill>
+                <a:latin typeface="Arial" pitchFamily="34" charset="0"/>
+                <a:ea typeface="Arial" pitchFamily="34" charset="-122"/>
+                <a:cs typeface="Arial" pitchFamily="34" charset="-120"/>
+              </a:rPr>
+              <a:t>CLOUD</a:t>
+            </a:r>
+            <a:pPr algn="r" indent="0" marL="0">
+              <a:buNone/>
+            </a:pPr>
+            <a:r>
+              <a:rPr lang="en-US" sz="1300" b="1" spc="300" kern="0" dirty="0">
+                <a:solidFill>
+                  <a:srgbClr val="EE5A29"/>
+                </a:solidFill>
+                <a:latin typeface="Arial" pitchFamily="34" charset="0"/>
+                <a:ea typeface="Arial" pitchFamily="34" charset="-122"/>
+                <a:cs typeface="Arial" pitchFamily="34" charset="-120"/>
+              </a:rPr>
+              <a:t>E</a:t>
+            </a:r>
+            <a:pPr algn="r" indent="0" marL="0">
+              <a:buNone/>
+            </a:pPr>
+            <a:r>
+              <a:rPr lang="en-US" sz="1300" b="1" spc="300" kern="0" dirty="0">
+                <a:solidFill>
+                  <a:srgbClr val="EE5A29"/>
+                </a:solidFill>
+                <a:latin typeface="Arial" pitchFamily="34" charset="0"/>
+                <a:ea typeface="Arial" pitchFamily="34" charset="-122"/>
+                <a:cs typeface="Arial" pitchFamily="34" charset="-120"/>
+              </a:rPr>
+              <a:t>RA</a:t>
+            </a:r>
+            <a:endParaRPr lang="en-US" sz="1300" dirty="0"/>
+          </a:p>
+        </p:txBody>
+      </p:sp>
+      <p:sp>
+        <p:nvSpPr>
+          <p:cNvPr id="3" name="Shape 1"/>
+          <p:cNvSpPr/>
+          <p:nvPr/>
+        </p:nvSpPr>
+        <p:spPr>
+          <a:xfrm>
+            <a:off x="566928" y="420624"/>
+            <a:ext cx="274320" cy="41148"/>
+          </a:xfrm>
+          <a:prstGeom prst="rect">
+            <a:avLst/>
+          </a:prstGeom>
+          <a:solidFill>
+            <a:srgbClr val="EE5A29"/>
+          </a:solidFill>
+          <a:ln/>
+        </p:spPr>
+      </p:sp>
+      <p:sp>
+        <p:nvSpPr>
+          <p:cNvPr id="4" name="Text 2"/>
+          <p:cNvSpPr/>
+          <p:nvPr/>
+        </p:nvSpPr>
+        <p:spPr>
+          <a:xfrm>
+            <a:off x="932688" y="274320"/>
+            <a:ext cx="6400800" cy="274320"/>
+          </a:xfrm>
+          <a:prstGeom prst="rect">
+            <a:avLst/>
+          </a:prstGeom>
+          <a:noFill/>
+          <a:ln/>
+        </p:spPr>
+        <p:txBody>
+          <a:bodyPr wrap="square" lIns="0" tIns="0" rIns="0" bIns="0" rtlCol="0" anchor="ctr"/>
+          <a:lstStyle/>
+          <a:p>
+            <a:pPr indent="0" marL="0">
+              <a:buNone/>
+            </a:pPr>
+            <a:r>
+              <a:rPr lang="en-US" sz="1050" b="1" spc="200" kern="0" dirty="0">
+                <a:solidFill>
+                  <a:srgbClr val="EE5A29"/>
+                </a:solidFill>
+                <a:latin typeface="Calibri" pitchFamily="34" charset="0"/>
+                <a:ea typeface="Calibri" pitchFamily="34" charset="-122"/>
+                <a:cs typeface="Calibri" pitchFamily="34" charset="-120"/>
+              </a:rPr>
+              <a:t>CLOUDERA AI</a:t>
+            </a:r>
+            <a:endParaRPr lang="en-US" sz="1050" dirty="0"/>
+          </a:p>
+        </p:txBody>
+      </p:sp>
+      <p:sp>
+        <p:nvSpPr>
+          <p:cNvPr id="5" name="Text 3"/>
+          <p:cNvSpPr/>
+          <p:nvPr/>
+        </p:nvSpPr>
+        <p:spPr>
+          <a:xfrm>
+            <a:off x="566928" y="566928"/>
+            <a:ext cx="8046720" cy="658368"/>
+          </a:xfrm>
+          <a:prstGeom prst="rect">
+            <a:avLst/>
+          </a:prstGeom>
+          <a:noFill/>
+          <a:ln/>
+        </p:spPr>
+        <p:txBody>
+          <a:bodyPr wrap="square" lIns="0" tIns="0" rIns="0" bIns="0" rtlCol="0" anchor="ctr"/>
+          <a:lstStyle/>
+          <a:p>
+            <a:pPr indent="0" marL="0">
+              <a:buNone/>
+            </a:pPr>
+            <a:r>
+              <a:rPr lang="en-US" sz="2700" b="1" dirty="0">
+                <a:solidFill>
+                  <a:srgbClr val="15154A"/>
+                </a:solidFill>
+                <a:latin typeface="Arial" pitchFamily="34" charset="0"/>
+                <a:ea typeface="Arial" pitchFamily="34" charset="-122"/>
+                <a:cs typeface="Arial" pitchFamily="34" charset="-120"/>
+              </a:rPr>
+              <a:t>Cloudera Agent Studio 3.0</a:t>
+            </a:r>
+            <a:endParaRPr lang="en-US" sz="2700" dirty="0"/>
+          </a:p>
+        </p:txBody>
+      </p:sp>
+      <p:sp>
+        <p:nvSpPr>
+          <p:cNvPr id="6" name="Text 4"/>
+          <p:cNvSpPr/>
+          <p:nvPr/>
+        </p:nvSpPr>
+        <p:spPr>
+          <a:xfrm>
+            <a:off x="566928" y="1444752"/>
+            <a:ext cx="4206240" cy="658368"/>
+          </a:xfrm>
+          <a:prstGeom prst="rect">
+            <a:avLst/>
+          </a:prstGeom>
+          <a:noFill/>
+          <a:ln/>
+        </p:spPr>
+        <p:txBody>
+          <a:bodyPr wrap="square" lIns="0" tIns="0" rIns="0" bIns="0" rtlCol="0" anchor="ctr"/>
+          <a:lstStyle/>
+          <a:p>
+            <a:pPr indent="0" marL="0">
+              <a:lnSpc>
+                <a:spcPct val="105000"/>
+              </a:lnSpc>
+              <a:buNone/>
+            </a:pPr>
+            <a:r>
+              <a:rPr lang="en-US" sz="1300" b="1" dirty="0">
+                <a:solidFill>
+                  <a:srgbClr val="4F4FF5"/>
+                </a:solidFill>
+                <a:latin typeface="Arial" pitchFamily="34" charset="0"/>
+                <a:ea typeface="Arial" pitchFamily="34" charset="-122"/>
+                <a:cs typeface="Arial" pitchFamily="34" charset="-120"/>
+              </a:rPr>
+              <a:t>A flexible low-code to high-code platform to create AI agents, tools, and multi-agent workflows — all through an intuitive UI.</a:t>
+            </a:r>
+            <a:endParaRPr lang="en-US" sz="1300" dirty="0"/>
+          </a:p>
+        </p:txBody>
+      </p:sp>
+      <p:sp>
+        <p:nvSpPr>
+          <p:cNvPr id="7" name="Shape 5"/>
+          <p:cNvSpPr/>
+          <p:nvPr/>
+        </p:nvSpPr>
+        <p:spPr>
+          <a:xfrm>
+            <a:off x="566928" y="2304288"/>
+            <a:ext cx="54864" cy="256032"/>
+          </a:xfrm>
+          <a:prstGeom prst="rect">
+            <a:avLst/>
+          </a:prstGeom>
+          <a:solidFill>
+            <a:srgbClr val="EE5A29"/>
+          </a:solidFill>
+          <a:ln/>
+        </p:spPr>
+      </p:sp>
+      <p:sp>
+        <p:nvSpPr>
+          <p:cNvPr id="8" name="Text 6"/>
+          <p:cNvSpPr/>
+          <p:nvPr/>
+        </p:nvSpPr>
+        <p:spPr>
+          <a:xfrm>
+            <a:off x="731520" y="2276856"/>
+            <a:ext cx="4023360" cy="182880"/>
+          </a:xfrm>
+          <a:prstGeom prst="rect">
+            <a:avLst/>
+          </a:prstGeom>
+          <a:noFill/>
+          <a:ln/>
+        </p:spPr>
+        <p:txBody>
+          <a:bodyPr wrap="square" lIns="0" tIns="0" rIns="0" bIns="0" rtlCol="0" anchor="ctr"/>
+          <a:lstStyle/>
+          <a:p>
+            <a:pPr indent="0" marL="0">
+              <a:buNone/>
+            </a:pPr>
+            <a:r>
+              <a:rPr lang="en-US" sz="1000" b="1" dirty="0">
+                <a:solidFill>
+                  <a:srgbClr val="15154A"/>
+                </a:solidFill>
+                <a:latin typeface="Arial" pitchFamily="34" charset="0"/>
+                <a:ea typeface="Arial" pitchFamily="34" charset="-122"/>
+                <a:cs typeface="Arial" pitchFamily="34" charset="-120"/>
+              </a:rPr>
+              <a:t>Agentic workflow builder</a:t>
+            </a:r>
+            <a:endParaRPr lang="en-US" sz="1000" dirty="0"/>
+          </a:p>
+        </p:txBody>
+      </p:sp>
+      <p:sp>
+        <p:nvSpPr>
+          <p:cNvPr id="9" name="Text 7"/>
+          <p:cNvSpPr/>
+          <p:nvPr/>
+        </p:nvSpPr>
+        <p:spPr>
+          <a:xfrm>
+            <a:off x="731520" y="2441448"/>
+            <a:ext cx="4023360" cy="164592"/>
+          </a:xfrm>
+          <a:prstGeom prst="rect">
+            <a:avLst/>
+          </a:prstGeom>
+          <a:noFill/>
+          <a:ln/>
+        </p:spPr>
+        <p:txBody>
+          <a:bodyPr wrap="square" lIns="0" tIns="0" rIns="0" bIns="0" rtlCol="0" anchor="ctr"/>
+          <a:lstStyle/>
+          <a:p>
+            <a:pPr indent="0" marL="0">
+              <a:buNone/>
+            </a:pPr>
+            <a:r>
+              <a:rPr lang="en-US" sz="850" dirty="0">
+                <a:solidFill>
+                  <a:srgbClr val="5A5A72"/>
+                </a:solidFill>
+                <a:latin typeface="Calibri" pitchFamily="34" charset="0"/>
+                <a:ea typeface="Calibri" pitchFamily="34" charset="-122"/>
+                <a:cs typeface="Calibri" pitchFamily="34" charset="-120"/>
+              </a:rPr>
+              <a:t>Create agents with tasks, tools &amp; roles; AI-assisted authoring</a:t>
+            </a:r>
+            <a:endParaRPr lang="en-US" sz="850" dirty="0"/>
+          </a:p>
+        </p:txBody>
+      </p:sp>
+      <p:sp>
+        <p:nvSpPr>
+          <p:cNvPr id="10" name="Shape 8"/>
+          <p:cNvSpPr/>
+          <p:nvPr/>
+        </p:nvSpPr>
+        <p:spPr>
+          <a:xfrm>
+            <a:off x="566928" y="2647188"/>
+            <a:ext cx="54864" cy="256032"/>
+          </a:xfrm>
+          <a:prstGeom prst="rect">
+            <a:avLst/>
+          </a:prstGeom>
+          <a:solidFill>
+            <a:srgbClr val="EE5A29"/>
+          </a:solidFill>
+          <a:ln/>
+        </p:spPr>
+      </p:sp>
+      <p:sp>
+        <p:nvSpPr>
+          <p:cNvPr id="11" name="Text 9"/>
+          <p:cNvSpPr/>
+          <p:nvPr/>
+        </p:nvSpPr>
+        <p:spPr>
+          <a:xfrm>
+            <a:off x="731520" y="2619756"/>
+            <a:ext cx="4023360" cy="182880"/>
+          </a:xfrm>
+          <a:prstGeom prst="rect">
+            <a:avLst/>
+          </a:prstGeom>
+          <a:noFill/>
+          <a:ln/>
+        </p:spPr>
+        <p:txBody>
+          <a:bodyPr wrap="square" lIns="0" tIns="0" rIns="0" bIns="0" rtlCol="0" anchor="ctr"/>
+          <a:lstStyle/>
+          <a:p>
+            <a:pPr indent="0" marL="0">
+              <a:buNone/>
+            </a:pPr>
+            <a:r>
+              <a:rPr lang="en-US" sz="1000" b="1" dirty="0">
+                <a:solidFill>
+                  <a:srgbClr val="15154A"/>
+                </a:solidFill>
+                <a:latin typeface="Arial" pitchFamily="34" charset="0"/>
+                <a:ea typeface="Arial" pitchFamily="34" charset="-122"/>
+                <a:cs typeface="Arial" pitchFamily="34" charset="-120"/>
+              </a:rPr>
+              <a:t>Tools Catalog</a:t>
+            </a:r>
+            <a:endParaRPr lang="en-US" sz="1000" dirty="0"/>
+          </a:p>
+        </p:txBody>
+      </p:sp>
+      <p:sp>
+        <p:nvSpPr>
+          <p:cNvPr id="12" name="Text 10"/>
+          <p:cNvSpPr/>
+          <p:nvPr/>
+        </p:nvSpPr>
+        <p:spPr>
+          <a:xfrm>
+            <a:off x="731520" y="2784348"/>
+            <a:ext cx="4023360" cy="164592"/>
+          </a:xfrm>
+          <a:prstGeom prst="rect">
+            <a:avLst/>
+          </a:prstGeom>
+          <a:noFill/>
+          <a:ln/>
+        </p:spPr>
+        <p:txBody>
+          <a:bodyPr wrap="square" lIns="0" tIns="0" rIns="0" bIns="0" rtlCol="0" anchor="ctr"/>
+          <a:lstStyle/>
+          <a:p>
+            <a:pPr indent="0" marL="0">
+              <a:buNone/>
+            </a:pPr>
+            <a:r>
+              <a:rPr lang="en-US" sz="850" dirty="0">
+                <a:solidFill>
+                  <a:srgbClr val="5A5A72"/>
+                </a:solidFill>
+                <a:latin typeface="Calibri" pitchFamily="34" charset="0"/>
+                <a:ea typeface="Calibri" pitchFamily="34" charset="-122"/>
+                <a:cs typeface="Calibri" pitchFamily="34" charset="-120"/>
+              </a:rPr>
+              <a:t>Built-in, custom Python, and MCP server tools — all reusable across workflows</a:t>
+            </a:r>
+            <a:endParaRPr lang="en-US" sz="850" dirty="0"/>
+          </a:p>
+        </p:txBody>
+      </p:sp>
+      <p:sp>
+        <p:nvSpPr>
+          <p:cNvPr id="13" name="Shape 11"/>
+          <p:cNvSpPr/>
+          <p:nvPr/>
+        </p:nvSpPr>
+        <p:spPr>
+          <a:xfrm>
+            <a:off x="566928" y="2990088"/>
+            <a:ext cx="54864" cy="256032"/>
+          </a:xfrm>
+          <a:prstGeom prst="rect">
+            <a:avLst/>
+          </a:prstGeom>
+          <a:solidFill>
+            <a:srgbClr val="EE5A29"/>
+          </a:solidFill>
+          <a:ln/>
+        </p:spPr>
+      </p:sp>
+      <p:sp>
+        <p:nvSpPr>
+          <p:cNvPr id="14" name="Text 12"/>
+          <p:cNvSpPr/>
+          <p:nvPr/>
+        </p:nvSpPr>
+        <p:spPr>
+          <a:xfrm>
+            <a:off x="731520" y="2962656"/>
+            <a:ext cx="4023360" cy="182880"/>
+          </a:xfrm>
+          <a:prstGeom prst="rect">
+            <a:avLst/>
+          </a:prstGeom>
+          <a:noFill/>
+          <a:ln/>
+        </p:spPr>
+        <p:txBody>
+          <a:bodyPr wrap="square" lIns="0" tIns="0" rIns="0" bIns="0" rtlCol="0" anchor="ctr"/>
+          <a:lstStyle/>
+          <a:p>
+            <a:pPr indent="0" marL="0">
+              <a:buNone/>
+            </a:pPr>
+            <a:r>
+              <a:rPr lang="en-US" sz="1000" b="1" dirty="0">
+                <a:solidFill>
+                  <a:srgbClr val="15154A"/>
+                </a:solidFill>
+                <a:latin typeface="Arial" pitchFamily="34" charset="0"/>
+                <a:ea typeface="Arial" pitchFamily="34" charset="-122"/>
+                <a:cs typeface="Arial" pitchFamily="34" charset="-120"/>
+              </a:rPr>
+              <a:t>Multi-LLM support</a:t>
+            </a:r>
+            <a:endParaRPr lang="en-US" sz="1000" dirty="0"/>
+          </a:p>
+        </p:txBody>
+      </p:sp>
+      <p:sp>
+        <p:nvSpPr>
+          <p:cNvPr id="15" name="Text 13"/>
+          <p:cNvSpPr/>
+          <p:nvPr/>
+        </p:nvSpPr>
+        <p:spPr>
+          <a:xfrm>
+            <a:off x="731520" y="3127248"/>
+            <a:ext cx="4023360" cy="164592"/>
+          </a:xfrm>
+          <a:prstGeom prst="rect">
+            <a:avLst/>
+          </a:prstGeom>
+          <a:noFill/>
+          <a:ln/>
+        </p:spPr>
+        <p:txBody>
+          <a:bodyPr wrap="square" lIns="0" tIns="0" rIns="0" bIns="0" rtlCol="0" anchor="ctr"/>
+          <a:lstStyle/>
+          <a:p>
+            <a:pPr indent="0" marL="0">
+              <a:buNone/>
+            </a:pPr>
+            <a:r>
+              <a:rPr lang="en-US" sz="850" dirty="0">
+                <a:solidFill>
+                  <a:srgbClr val="5A5A72"/>
+                </a:solidFill>
+                <a:latin typeface="Calibri" pitchFamily="34" charset="0"/>
+                <a:ea typeface="Calibri" pitchFamily="34" charset="-122"/>
+                <a:cs typeface="Calibri" pitchFamily="34" charset="-120"/>
+              </a:rPr>
+              <a:t>CAI Inferencing, Azure OpenAI, Gemini, Anthropic, any OpenAI-compatible endpoint</a:t>
+            </a:r>
+            <a:endParaRPr lang="en-US" sz="850" dirty="0"/>
+          </a:p>
+        </p:txBody>
+      </p:sp>
+      <p:sp>
+        <p:nvSpPr>
+          <p:cNvPr id="16" name="Shape 14"/>
+          <p:cNvSpPr/>
+          <p:nvPr/>
+        </p:nvSpPr>
+        <p:spPr>
+          <a:xfrm>
+            <a:off x="566928" y="3332988"/>
+            <a:ext cx="54864" cy="256032"/>
+          </a:xfrm>
+          <a:prstGeom prst="rect">
+            <a:avLst/>
+          </a:prstGeom>
+          <a:solidFill>
+            <a:srgbClr val="EE5A29"/>
+          </a:solidFill>
+          <a:ln/>
+        </p:spPr>
+      </p:sp>
+      <p:sp>
+        <p:nvSpPr>
+          <p:cNvPr id="17" name="Text 15"/>
+          <p:cNvSpPr/>
+          <p:nvPr/>
+        </p:nvSpPr>
+        <p:spPr>
+          <a:xfrm>
+            <a:off x="731520" y="3305556"/>
+            <a:ext cx="4023360" cy="182880"/>
+          </a:xfrm>
+          <a:prstGeom prst="rect">
+            <a:avLst/>
+          </a:prstGeom>
+          <a:noFill/>
+          <a:ln/>
+        </p:spPr>
+        <p:txBody>
+          <a:bodyPr wrap="square" lIns="0" tIns="0" rIns="0" bIns="0" rtlCol="0" anchor="ctr"/>
+          <a:lstStyle/>
+          <a:p>
+            <a:pPr indent="0" marL="0">
+              <a:buNone/>
+            </a:pPr>
+            <a:r>
+              <a:rPr lang="en-US" sz="1000" b="1" dirty="0">
+                <a:solidFill>
+                  <a:srgbClr val="15154A"/>
+                </a:solidFill>
+                <a:latin typeface="Arial" pitchFamily="34" charset="0"/>
+                <a:ea typeface="Arial" pitchFamily="34" charset="-122"/>
+                <a:cs typeface="Arial" pitchFamily="34" charset="-120"/>
+              </a:rPr>
+              <a:t>Test &amp; debug</a:t>
+            </a:r>
+            <a:endParaRPr lang="en-US" sz="1000" dirty="0"/>
+          </a:p>
+        </p:txBody>
+      </p:sp>
+      <p:sp>
+        <p:nvSpPr>
+          <p:cNvPr id="18" name="Text 16"/>
+          <p:cNvSpPr/>
+          <p:nvPr/>
+        </p:nvSpPr>
+        <p:spPr>
+          <a:xfrm>
+            <a:off x="731520" y="3470148"/>
+            <a:ext cx="4023360" cy="164592"/>
+          </a:xfrm>
+          <a:prstGeom prst="rect">
+            <a:avLst/>
+          </a:prstGeom>
+          <a:noFill/>
+          <a:ln/>
+        </p:spPr>
+        <p:txBody>
+          <a:bodyPr wrap="square" lIns="0" tIns="0" rIns="0" bIns="0" rtlCol="0" anchor="ctr"/>
+          <a:lstStyle/>
+          <a:p>
+            <a:pPr indent="0" marL="0">
+              <a:buNone/>
+            </a:pPr>
+            <a:r>
+              <a:rPr lang="en-US" sz="850" dirty="0">
+                <a:solidFill>
+                  <a:srgbClr val="5A5A72"/>
+                </a:solidFill>
+                <a:latin typeface="Calibri" pitchFamily="34" charset="0"/>
+                <a:ea typeface="Calibri" pitchFamily="34" charset="-122"/>
+                <a:cs typeface="Calibri" pitchFamily="34" charset="-120"/>
+              </a:rPr>
+              <a:t>Logs, playback, and visual debugger in the Test panel</a:t>
+            </a:r>
+            <a:endParaRPr lang="en-US" sz="850" dirty="0"/>
+          </a:p>
+        </p:txBody>
+      </p:sp>
+      <p:sp>
+        <p:nvSpPr>
+          <p:cNvPr id="19" name="Shape 17"/>
+          <p:cNvSpPr/>
+          <p:nvPr/>
+        </p:nvSpPr>
+        <p:spPr>
+          <a:xfrm>
+            <a:off x="566928" y="3675888"/>
+            <a:ext cx="54864" cy="256032"/>
+          </a:xfrm>
+          <a:prstGeom prst="rect">
+            <a:avLst/>
+          </a:prstGeom>
+          <a:solidFill>
+            <a:srgbClr val="EE5A29"/>
+          </a:solidFill>
+          <a:ln/>
+        </p:spPr>
+      </p:sp>
+      <p:sp>
+        <p:nvSpPr>
+          <p:cNvPr id="20" name="Text 18"/>
+          <p:cNvSpPr/>
+          <p:nvPr/>
+        </p:nvSpPr>
+        <p:spPr>
+          <a:xfrm>
+            <a:off x="731520" y="3648456"/>
+            <a:ext cx="4023360" cy="182880"/>
+          </a:xfrm>
+          <a:prstGeom prst="rect">
+            <a:avLst/>
+          </a:prstGeom>
+          <a:noFill/>
+          <a:ln/>
+        </p:spPr>
+        <p:txBody>
+          <a:bodyPr wrap="square" lIns="0" tIns="0" rIns="0" bIns="0" rtlCol="0" anchor="ctr"/>
+          <a:lstStyle/>
+          <a:p>
+            <a:pPr indent="0" marL="0">
+              <a:buNone/>
+            </a:pPr>
+            <a:r>
+              <a:rPr lang="en-US" sz="1000" b="1" dirty="0">
+                <a:solidFill>
+                  <a:srgbClr val="15154A"/>
+                </a:solidFill>
+                <a:latin typeface="Arial" pitchFamily="34" charset="0"/>
+                <a:ea typeface="Arial" pitchFamily="34" charset="-122"/>
+                <a:cs typeface="Arial" pitchFamily="34" charset="-120"/>
+              </a:rPr>
+              <a:t>Deploy as endpoint</a:t>
+            </a:r>
+            <a:endParaRPr lang="en-US" sz="1000" dirty="0"/>
+          </a:p>
+        </p:txBody>
+      </p:sp>
+      <p:sp>
+        <p:nvSpPr>
+          <p:cNvPr id="21" name="Text 19"/>
+          <p:cNvSpPr/>
+          <p:nvPr/>
+        </p:nvSpPr>
+        <p:spPr>
+          <a:xfrm>
+            <a:off x="731520" y="3813048"/>
+            <a:ext cx="4023360" cy="164592"/>
+          </a:xfrm>
+          <a:prstGeom prst="rect">
+            <a:avLst/>
+          </a:prstGeom>
+          <a:noFill/>
+          <a:ln/>
+        </p:spPr>
+        <p:txBody>
+          <a:bodyPr wrap="square" lIns="0" tIns="0" rIns="0" bIns="0" rtlCol="0" anchor="ctr"/>
+          <a:lstStyle/>
+          <a:p>
+            <a:pPr indent="0" marL="0">
+              <a:buNone/>
+            </a:pPr>
+            <a:r>
+              <a:rPr lang="en-US" sz="850" dirty="0">
+                <a:solidFill>
+                  <a:srgbClr val="5A5A72"/>
+                </a:solidFill>
+                <a:latin typeface="Calibri" pitchFamily="34" charset="0"/>
+                <a:ea typeface="Calibri" pitchFamily="34" charset="-122"/>
+                <a:cs typeface="Calibri" pitchFamily="34" charset="-120"/>
+              </a:rPr>
+              <a:t>Auto-generated UI; deploy workflows as APIs with one click</a:t>
+            </a:r>
+            <a:endParaRPr lang="en-US" sz="850" dirty="0"/>
+          </a:p>
+        </p:txBody>
+      </p:sp>
+      <p:sp>
+        <p:nvSpPr>
+          <p:cNvPr id="22" name="Shape 20"/>
+          <p:cNvSpPr/>
+          <p:nvPr/>
+        </p:nvSpPr>
+        <p:spPr>
+          <a:xfrm>
+            <a:off x="566928" y="4018788"/>
+            <a:ext cx="54864" cy="256032"/>
+          </a:xfrm>
+          <a:prstGeom prst="rect">
+            <a:avLst/>
+          </a:prstGeom>
+          <a:solidFill>
+            <a:srgbClr val="EE5A29"/>
+          </a:solidFill>
+          <a:ln/>
+        </p:spPr>
+      </p:sp>
+      <p:sp>
+        <p:nvSpPr>
+          <p:cNvPr id="23" name="Text 21"/>
+          <p:cNvSpPr/>
+          <p:nvPr/>
+        </p:nvSpPr>
+        <p:spPr>
+          <a:xfrm>
+            <a:off x="731520" y="3991356"/>
+            <a:ext cx="4023360" cy="182880"/>
+          </a:xfrm>
+          <a:prstGeom prst="rect">
+            <a:avLst/>
+          </a:prstGeom>
+          <a:noFill/>
+          <a:ln/>
+        </p:spPr>
+        <p:txBody>
+          <a:bodyPr wrap="square" lIns="0" tIns="0" rIns="0" bIns="0" rtlCol="0" anchor="ctr"/>
+          <a:lstStyle/>
+          <a:p>
+            <a:pPr indent="0" marL="0">
+              <a:buNone/>
+            </a:pPr>
+            <a:r>
+              <a:rPr lang="en-US" sz="1000" b="1" dirty="0">
+                <a:solidFill>
+                  <a:srgbClr val="15154A"/>
+                </a:solidFill>
+                <a:latin typeface="Arial" pitchFamily="34" charset="0"/>
+                <a:ea typeface="Arial" pitchFamily="34" charset="-122"/>
+                <a:cs typeface="Arial" pitchFamily="34" charset="-120"/>
+              </a:rPr>
+              <a:t>Built-in observability</a:t>
+            </a:r>
+            <a:endParaRPr lang="en-US" sz="1000" dirty="0"/>
+          </a:p>
+        </p:txBody>
+      </p:sp>
+      <p:sp>
+        <p:nvSpPr>
+          <p:cNvPr id="24" name="Text 22"/>
+          <p:cNvSpPr/>
+          <p:nvPr/>
+        </p:nvSpPr>
+        <p:spPr>
+          <a:xfrm>
+            <a:off x="731520" y="4155948"/>
+            <a:ext cx="4023360" cy="164592"/>
+          </a:xfrm>
+          <a:prstGeom prst="rect">
+            <a:avLst/>
+          </a:prstGeom>
+          <a:noFill/>
+          <a:ln/>
+        </p:spPr>
+        <p:txBody>
+          <a:bodyPr wrap="square" lIns="0" tIns="0" rIns="0" bIns="0" rtlCol="0" anchor="ctr"/>
+          <a:lstStyle/>
+          <a:p>
+            <a:pPr indent="0" marL="0">
+              <a:buNone/>
+            </a:pPr>
+            <a:r>
+              <a:rPr lang="en-US" sz="850" dirty="0">
+                <a:solidFill>
+                  <a:srgbClr val="5A5A72"/>
+                </a:solidFill>
+                <a:latin typeface="Calibri" pitchFamily="34" charset="0"/>
+                <a:ea typeface="Calibri" pitchFamily="34" charset="-122"/>
+                <a:cs typeface="Calibri" pitchFamily="34" charset="-120"/>
+              </a:rPr>
+              <a:t>Phoenix (Arize) tracing integrated; monitor every agent run</a:t>
+            </a:r>
+            <a:endParaRPr lang="en-US" sz="850" dirty="0"/>
+          </a:p>
+        </p:txBody>
+      </p:sp>
+      <p:sp>
+        <p:nvSpPr>
+          <p:cNvPr id="25" name="Shape 23"/>
+          <p:cNvSpPr/>
+          <p:nvPr/>
+        </p:nvSpPr>
+        <p:spPr>
+          <a:xfrm>
+            <a:off x="566928" y="4361688"/>
+            <a:ext cx="54864" cy="256032"/>
+          </a:xfrm>
+          <a:prstGeom prst="rect">
+            <a:avLst/>
+          </a:prstGeom>
+          <a:solidFill>
+            <a:srgbClr val="EE5A29"/>
+          </a:solidFill>
+          <a:ln/>
+        </p:spPr>
+      </p:sp>
+      <p:sp>
+        <p:nvSpPr>
+          <p:cNvPr id="26" name="Text 24"/>
+          <p:cNvSpPr/>
+          <p:nvPr/>
+        </p:nvSpPr>
+        <p:spPr>
+          <a:xfrm>
+            <a:off x="731520" y="4334256"/>
+            <a:ext cx="4023360" cy="182880"/>
+          </a:xfrm>
+          <a:prstGeom prst="rect">
+            <a:avLst/>
+          </a:prstGeom>
+          <a:noFill/>
+          <a:ln/>
+        </p:spPr>
+        <p:txBody>
+          <a:bodyPr wrap="square" lIns="0" tIns="0" rIns="0" bIns="0" rtlCol="0" anchor="ctr"/>
+          <a:lstStyle/>
+          <a:p>
+            <a:pPr indent="0" marL="0">
+              <a:buNone/>
+            </a:pPr>
+            <a:r>
+              <a:rPr lang="en-US" sz="1000" b="1" dirty="0">
+                <a:solidFill>
+                  <a:srgbClr val="15154A"/>
+                </a:solidFill>
+                <a:latin typeface="Arial" pitchFamily="34" charset="0"/>
+                <a:ea typeface="Arial" pitchFamily="34" charset="-122"/>
+                <a:cs typeface="Arial" pitchFamily="34" charset="-120"/>
+              </a:rPr>
+              <a:t>Guardrails</a:t>
+            </a:r>
+            <a:endParaRPr lang="en-US" sz="1000" dirty="0"/>
+          </a:p>
+        </p:txBody>
+      </p:sp>
+      <p:sp>
+        <p:nvSpPr>
+          <p:cNvPr id="27" name="Text 25"/>
+          <p:cNvSpPr/>
+          <p:nvPr/>
+        </p:nvSpPr>
+        <p:spPr>
+          <a:xfrm>
+            <a:off x="731520" y="4498848"/>
+            <a:ext cx="4023360" cy="164592"/>
+          </a:xfrm>
+          <a:prstGeom prst="rect">
+            <a:avLst/>
+          </a:prstGeom>
+          <a:noFill/>
+          <a:ln/>
+        </p:spPr>
+        <p:txBody>
+          <a:bodyPr wrap="square" lIns="0" tIns="0" rIns="0" bIns="0" rtlCol="0" anchor="ctr"/>
+          <a:lstStyle/>
+          <a:p>
+            <a:pPr indent="0" marL="0">
+              <a:buNone/>
+            </a:pPr>
+            <a:r>
+              <a:rPr lang="en-US" sz="850" dirty="0">
+                <a:solidFill>
+                  <a:srgbClr val="5A5A72"/>
+                </a:solidFill>
+                <a:latin typeface="Calibri" pitchFamily="34" charset="0"/>
+                <a:ea typeface="Calibri" pitchFamily="34" charset="-122"/>
+                <a:cs typeface="Calibri" pitchFamily="34" charset="-120"/>
+              </a:rPr>
+              <a:t>Secure workflows with configurable safety constraints</a:t>
+            </a:r>
+            <a:endParaRPr lang="en-US" sz="850" dirty="0"/>
+          </a:p>
+        </p:txBody>
+      </p:sp>
+      <p:sp>
+        <p:nvSpPr>
+          <p:cNvPr id="28" name="Shape 26"/>
+          <p:cNvSpPr/>
+          <p:nvPr/>
+        </p:nvSpPr>
+        <p:spPr>
+          <a:xfrm>
+            <a:off x="5047488" y="1389888"/>
+            <a:ext cx="3529584" cy="3291840"/>
+          </a:xfrm>
+          <a:prstGeom prst="roundRect">
+            <a:avLst>
+              <a:gd name="adj" fmla="val 2778"/>
+            </a:avLst>
+          </a:prstGeom>
+          <a:solidFill>
+            <a:srgbClr val="F6F6FB"/>
+          </a:solidFill>
+          <a:ln w="19050">
+            <a:solidFill>
+              <a:srgbClr val="E2E2EC"/>
+            </a:solidFill>
+            <a:prstDash val="solid"/>
+          </a:ln>
+        </p:spPr>
+      </p:sp>
+      <p:sp>
+        <p:nvSpPr>
+          <p:cNvPr id="29" name="Text 27"/>
+          <p:cNvSpPr/>
+          <p:nvPr/>
+        </p:nvSpPr>
+        <p:spPr>
+          <a:xfrm>
+            <a:off x="5230368" y="1517904"/>
+            <a:ext cx="3163824" cy="256032"/>
+          </a:xfrm>
+          <a:prstGeom prst="rect">
+            <a:avLst/>
+          </a:prstGeom>
+          <a:noFill/>
+          <a:ln/>
+        </p:spPr>
+        <p:txBody>
+          <a:bodyPr wrap="square" lIns="0" tIns="0" rIns="0" bIns="0" rtlCol="0" anchor="ctr"/>
+          <a:lstStyle/>
+          <a:p>
+            <a:pPr algn="ctr" indent="0" marL="0">
+              <a:buNone/>
+            </a:pPr>
+            <a:r>
+              <a:rPr lang="en-US" sz="1100" b="1" spc="150" kern="0" dirty="0">
+                <a:solidFill>
+                  <a:srgbClr val="15154A"/>
+                </a:solidFill>
+                <a:latin typeface="Arial" pitchFamily="34" charset="0"/>
+                <a:ea typeface="Arial" pitchFamily="34" charset="-122"/>
+                <a:cs typeface="Arial" pitchFamily="34" charset="-120"/>
+              </a:rPr>
+              <a:t>AGENT STUDIO</a:t>
+            </a:r>
+            <a:endParaRPr lang="en-US" sz="1100" dirty="0"/>
+          </a:p>
+        </p:txBody>
+      </p:sp>
+      <p:sp>
+        <p:nvSpPr>
+          <p:cNvPr id="30" name="Shape 28"/>
+          <p:cNvSpPr/>
+          <p:nvPr/>
+        </p:nvSpPr>
+        <p:spPr>
+          <a:xfrm>
+            <a:off x="5212080" y="1920240"/>
+            <a:ext cx="987552" cy="402336"/>
+          </a:xfrm>
+          <a:prstGeom prst="roundRect">
+            <a:avLst>
+              <a:gd name="adj" fmla="val 15909"/>
+            </a:avLst>
+          </a:prstGeom>
+          <a:solidFill>
+            <a:srgbClr val="FFFFFF"/>
+          </a:solidFill>
+          <a:ln w="12700">
+            <a:solidFill>
+              <a:srgbClr val="4F4FF5"/>
+            </a:solidFill>
+            <a:prstDash val="solid"/>
+          </a:ln>
+        </p:spPr>
+      </p:sp>
+      <p:sp>
+        <p:nvSpPr>
+          <p:cNvPr id="31" name="Text 29"/>
+          <p:cNvSpPr/>
+          <p:nvPr/>
+        </p:nvSpPr>
+        <p:spPr>
+          <a:xfrm>
+            <a:off x="5212080" y="1920240"/>
+            <a:ext cx="987552" cy="402336"/>
+          </a:xfrm>
+          <a:prstGeom prst="rect">
+            <a:avLst/>
+          </a:prstGeom>
+          <a:noFill/>
+          <a:ln/>
+        </p:spPr>
+        <p:txBody>
+          <a:bodyPr wrap="square" lIns="0" tIns="0" rIns="0" bIns="0" rtlCol="0" anchor="ctr"/>
+          <a:lstStyle/>
+          <a:p>
+            <a:pPr algn="ctr" indent="0" marL="0">
+              <a:buNone/>
+            </a:pPr>
+            <a:r>
+              <a:rPr lang="en-US" sz="900" b="1" dirty="0">
+                <a:solidFill>
+                  <a:srgbClr val="4F4FF5"/>
+                </a:solidFill>
+                <a:latin typeface="Calibri" pitchFamily="34" charset="0"/>
+                <a:ea typeface="Calibri" pitchFamily="34" charset="-122"/>
+                <a:cs typeface="Calibri" pitchFamily="34" charset="-120"/>
+              </a:rPr>
+              <a:t>Agent 1</a:t>
+            </a:r>
+            <a:endParaRPr lang="en-US" sz="900" dirty="0"/>
+          </a:p>
+        </p:txBody>
+      </p:sp>
+      <p:sp>
+        <p:nvSpPr>
+          <p:cNvPr id="32" name="Shape 30"/>
+          <p:cNvSpPr/>
+          <p:nvPr/>
+        </p:nvSpPr>
+        <p:spPr>
+          <a:xfrm>
+            <a:off x="5248656" y="2395728"/>
+            <a:ext cx="420624" cy="237744"/>
+          </a:xfrm>
+          <a:prstGeom prst="roundRect">
+            <a:avLst>
+              <a:gd name="adj" fmla="val 15385"/>
+            </a:avLst>
+          </a:prstGeom>
+          <a:solidFill>
+            <a:srgbClr val="FFF3EE"/>
+          </a:solidFill>
+          <a:ln/>
+        </p:spPr>
+      </p:sp>
+      <p:sp>
+        <p:nvSpPr>
+          <p:cNvPr id="33" name="Text 31"/>
+          <p:cNvSpPr/>
+          <p:nvPr/>
+        </p:nvSpPr>
+        <p:spPr>
+          <a:xfrm>
+            <a:off x="5248656" y="2395728"/>
+            <a:ext cx="420624" cy="237744"/>
+          </a:xfrm>
+          <a:prstGeom prst="rect">
+            <a:avLst/>
+          </a:prstGeom>
+          <a:noFill/>
+          <a:ln/>
+        </p:spPr>
+        <p:txBody>
+          <a:bodyPr wrap="square" lIns="0" tIns="0" rIns="0" bIns="0" rtlCol="0" anchor="ctr"/>
+          <a:lstStyle/>
+          <a:p>
+            <a:pPr algn="ctr" indent="0" marL="0">
+              <a:buNone/>
+            </a:pPr>
+            <a:r>
+              <a:rPr lang="en-US" sz="750" dirty="0">
+                <a:solidFill>
+                  <a:srgbClr val="EE5A29"/>
+                </a:solidFill>
+                <a:latin typeface="Calibri" pitchFamily="34" charset="0"/>
+                <a:ea typeface="Calibri" pitchFamily="34" charset="-122"/>
+                <a:cs typeface="Calibri" pitchFamily="34" charset="-120"/>
+              </a:rPr>
+              <a:t>Tool 1</a:t>
+            </a:r>
+            <a:endParaRPr lang="en-US" sz="750" dirty="0"/>
+          </a:p>
+        </p:txBody>
+      </p:sp>
+      <p:sp>
+        <p:nvSpPr>
+          <p:cNvPr id="34" name="Shape 32"/>
+          <p:cNvSpPr/>
+          <p:nvPr/>
+        </p:nvSpPr>
+        <p:spPr>
+          <a:xfrm>
+            <a:off x="5742432" y="2395728"/>
+            <a:ext cx="420624" cy="237744"/>
+          </a:xfrm>
+          <a:prstGeom prst="roundRect">
+            <a:avLst>
+              <a:gd name="adj" fmla="val 15385"/>
+            </a:avLst>
+          </a:prstGeom>
+          <a:solidFill>
+            <a:srgbClr val="FFF3EE"/>
+          </a:solidFill>
+          <a:ln/>
+        </p:spPr>
+      </p:sp>
+      <p:sp>
+        <p:nvSpPr>
+          <p:cNvPr id="35" name="Text 33"/>
+          <p:cNvSpPr/>
+          <p:nvPr/>
+        </p:nvSpPr>
+        <p:spPr>
+          <a:xfrm>
+            <a:off x="5742432" y="2395728"/>
+            <a:ext cx="420624" cy="237744"/>
+          </a:xfrm>
+          <a:prstGeom prst="rect">
+            <a:avLst/>
+          </a:prstGeom>
+          <a:noFill/>
+          <a:ln/>
+        </p:spPr>
+        <p:txBody>
+          <a:bodyPr wrap="square" lIns="0" tIns="0" rIns="0" bIns="0" rtlCol="0" anchor="ctr"/>
+          <a:lstStyle/>
+          <a:p>
+            <a:pPr algn="ctr" indent="0" marL="0">
+              <a:buNone/>
+            </a:pPr>
+            <a:r>
+              <a:rPr lang="en-US" sz="750" dirty="0">
+                <a:solidFill>
+                  <a:srgbClr val="EE5A29"/>
+                </a:solidFill>
+                <a:latin typeface="Calibri" pitchFamily="34" charset="0"/>
+                <a:ea typeface="Calibri" pitchFamily="34" charset="-122"/>
+                <a:cs typeface="Calibri" pitchFamily="34" charset="-120"/>
+              </a:rPr>
+              <a:t>Tool 2</a:t>
+            </a:r>
+            <a:endParaRPr lang="en-US" sz="750" dirty="0"/>
+          </a:p>
+        </p:txBody>
+      </p:sp>
+      <p:sp>
+        <p:nvSpPr>
+          <p:cNvPr id="36" name="Shape 34"/>
+          <p:cNvSpPr/>
+          <p:nvPr/>
+        </p:nvSpPr>
+        <p:spPr>
+          <a:xfrm>
+            <a:off x="6309360" y="1920240"/>
+            <a:ext cx="987552" cy="402336"/>
+          </a:xfrm>
+          <a:prstGeom prst="roundRect">
+            <a:avLst>
+              <a:gd name="adj" fmla="val 15909"/>
+            </a:avLst>
+          </a:prstGeom>
+          <a:solidFill>
+            <a:srgbClr val="E9E9FE"/>
+          </a:solidFill>
+          <a:ln w="12700">
+            <a:solidFill>
+              <a:srgbClr val="4F4FF5"/>
+            </a:solidFill>
+            <a:prstDash val="solid"/>
+          </a:ln>
+        </p:spPr>
+      </p:sp>
+      <p:sp>
+        <p:nvSpPr>
+          <p:cNvPr id="37" name="Text 35"/>
+          <p:cNvSpPr/>
+          <p:nvPr/>
+        </p:nvSpPr>
+        <p:spPr>
+          <a:xfrm>
+            <a:off x="6309360" y="1920240"/>
+            <a:ext cx="987552" cy="402336"/>
+          </a:xfrm>
+          <a:prstGeom prst="rect">
+            <a:avLst/>
+          </a:prstGeom>
+          <a:noFill/>
+          <a:ln/>
+        </p:spPr>
+        <p:txBody>
+          <a:bodyPr wrap="square" lIns="0" tIns="0" rIns="0" bIns="0" rtlCol="0" anchor="ctr"/>
+          <a:lstStyle/>
+          <a:p>
+            <a:pPr algn="ctr" indent="0" marL="0">
+              <a:buNone/>
+            </a:pPr>
+            <a:r>
+              <a:rPr lang="en-US" sz="900" b="1" dirty="0">
+                <a:solidFill>
+                  <a:srgbClr val="4F4FF5"/>
+                </a:solidFill>
+                <a:latin typeface="Calibri" pitchFamily="34" charset="0"/>
+                <a:ea typeface="Calibri" pitchFamily="34" charset="-122"/>
+                <a:cs typeface="Calibri" pitchFamily="34" charset="-120"/>
+              </a:rPr>
+              <a:t>Agent 2</a:t>
+            </a:r>
+            <a:endParaRPr lang="en-US" sz="900" dirty="0"/>
+          </a:p>
+        </p:txBody>
+      </p:sp>
+      <p:sp>
+        <p:nvSpPr>
+          <p:cNvPr id="38" name="Shape 36"/>
+          <p:cNvSpPr/>
+          <p:nvPr/>
+        </p:nvSpPr>
+        <p:spPr>
+          <a:xfrm>
+            <a:off x="6345936" y="2395728"/>
+            <a:ext cx="420624" cy="237744"/>
+          </a:xfrm>
+          <a:prstGeom prst="roundRect">
+            <a:avLst>
+              <a:gd name="adj" fmla="val 15385"/>
+            </a:avLst>
+          </a:prstGeom>
+          <a:solidFill>
+            <a:srgbClr val="FFF3EE"/>
+          </a:solidFill>
+          <a:ln/>
+        </p:spPr>
+      </p:sp>
+      <p:sp>
+        <p:nvSpPr>
+          <p:cNvPr id="39" name="Text 37"/>
+          <p:cNvSpPr/>
+          <p:nvPr/>
+        </p:nvSpPr>
+        <p:spPr>
+          <a:xfrm>
+            <a:off x="6345936" y="2395728"/>
+            <a:ext cx="420624" cy="237744"/>
+          </a:xfrm>
+          <a:prstGeom prst="rect">
+            <a:avLst/>
+          </a:prstGeom>
+          <a:noFill/>
+          <a:ln/>
+        </p:spPr>
+        <p:txBody>
+          <a:bodyPr wrap="square" lIns="0" tIns="0" rIns="0" bIns="0" rtlCol="0" anchor="ctr"/>
+          <a:lstStyle/>
+          <a:p>
+            <a:pPr algn="ctr" indent="0" marL="0">
+              <a:buNone/>
+            </a:pPr>
+            <a:r>
+              <a:rPr lang="en-US" sz="750" dirty="0">
+                <a:solidFill>
+                  <a:srgbClr val="EE5A29"/>
+                </a:solidFill>
+                <a:latin typeface="Calibri" pitchFamily="34" charset="0"/>
+                <a:ea typeface="Calibri" pitchFamily="34" charset="-122"/>
+                <a:cs typeface="Calibri" pitchFamily="34" charset="-120"/>
+              </a:rPr>
+              <a:t>Tool 1</a:t>
+            </a:r>
+            <a:endParaRPr lang="en-US" sz="750" dirty="0"/>
+          </a:p>
+        </p:txBody>
+      </p:sp>
+      <p:sp>
+        <p:nvSpPr>
+          <p:cNvPr id="40" name="Shape 38"/>
+          <p:cNvSpPr/>
+          <p:nvPr/>
+        </p:nvSpPr>
+        <p:spPr>
+          <a:xfrm>
+            <a:off x="6839712" y="2395728"/>
+            <a:ext cx="420624" cy="237744"/>
+          </a:xfrm>
+          <a:prstGeom prst="roundRect">
+            <a:avLst>
+              <a:gd name="adj" fmla="val 15385"/>
+            </a:avLst>
+          </a:prstGeom>
+          <a:solidFill>
+            <a:srgbClr val="FFF3EE"/>
+          </a:solidFill>
+          <a:ln/>
+        </p:spPr>
+      </p:sp>
+      <p:sp>
+        <p:nvSpPr>
+          <p:cNvPr id="41" name="Text 39"/>
+          <p:cNvSpPr/>
+          <p:nvPr/>
+        </p:nvSpPr>
+        <p:spPr>
+          <a:xfrm>
+            <a:off x="6839712" y="2395728"/>
+            <a:ext cx="420624" cy="237744"/>
+          </a:xfrm>
+          <a:prstGeom prst="rect">
+            <a:avLst/>
+          </a:prstGeom>
+          <a:noFill/>
+          <a:ln/>
+        </p:spPr>
+        <p:txBody>
+          <a:bodyPr wrap="square" lIns="0" tIns="0" rIns="0" bIns="0" rtlCol="0" anchor="ctr"/>
+          <a:lstStyle/>
+          <a:p>
+            <a:pPr algn="ctr" indent="0" marL="0">
+              <a:buNone/>
+            </a:pPr>
+            <a:r>
+              <a:rPr lang="en-US" sz="750" dirty="0">
+                <a:solidFill>
+                  <a:srgbClr val="EE5A29"/>
+                </a:solidFill>
+                <a:latin typeface="Calibri" pitchFamily="34" charset="0"/>
+                <a:ea typeface="Calibri" pitchFamily="34" charset="-122"/>
+                <a:cs typeface="Calibri" pitchFamily="34" charset="-120"/>
+              </a:rPr>
+              <a:t>Tool 2</a:t>
+            </a:r>
+            <a:endParaRPr lang="en-US" sz="750" dirty="0"/>
+          </a:p>
+        </p:txBody>
+      </p:sp>
+      <p:sp>
+        <p:nvSpPr>
+          <p:cNvPr id="42" name="Shape 40"/>
+          <p:cNvSpPr/>
+          <p:nvPr/>
+        </p:nvSpPr>
+        <p:spPr>
+          <a:xfrm>
+            <a:off x="7406640" y="1920240"/>
+            <a:ext cx="987552" cy="402336"/>
+          </a:xfrm>
+          <a:prstGeom prst="roundRect">
+            <a:avLst>
+              <a:gd name="adj" fmla="val 15909"/>
+            </a:avLst>
+          </a:prstGeom>
+          <a:solidFill>
+            <a:srgbClr val="FFFFFF"/>
+          </a:solidFill>
+          <a:ln w="12700">
+            <a:solidFill>
+              <a:srgbClr val="4F4FF5"/>
+            </a:solidFill>
+            <a:prstDash val="solid"/>
+          </a:ln>
+        </p:spPr>
+      </p:sp>
+      <p:sp>
+        <p:nvSpPr>
+          <p:cNvPr id="43" name="Text 41"/>
+          <p:cNvSpPr/>
+          <p:nvPr/>
+        </p:nvSpPr>
+        <p:spPr>
+          <a:xfrm>
+            <a:off x="7406640" y="1920240"/>
+            <a:ext cx="987552" cy="402336"/>
+          </a:xfrm>
+          <a:prstGeom prst="rect">
+            <a:avLst/>
+          </a:prstGeom>
+          <a:noFill/>
+          <a:ln/>
+        </p:spPr>
+        <p:txBody>
+          <a:bodyPr wrap="square" lIns="0" tIns="0" rIns="0" bIns="0" rtlCol="0" anchor="ctr"/>
+          <a:lstStyle/>
+          <a:p>
+            <a:pPr algn="ctr" indent="0" marL="0">
+              <a:buNone/>
+            </a:pPr>
+            <a:r>
+              <a:rPr lang="en-US" sz="900" b="1" dirty="0">
+                <a:solidFill>
+                  <a:srgbClr val="4F4FF5"/>
+                </a:solidFill>
+                <a:latin typeface="Calibri" pitchFamily="34" charset="0"/>
+                <a:ea typeface="Calibri" pitchFamily="34" charset="-122"/>
+                <a:cs typeface="Calibri" pitchFamily="34" charset="-120"/>
+              </a:rPr>
+              <a:t>Agent 3</a:t>
+            </a:r>
+            <a:endParaRPr lang="en-US" sz="900" dirty="0"/>
+          </a:p>
+        </p:txBody>
+      </p:sp>
+      <p:sp>
+        <p:nvSpPr>
+          <p:cNvPr id="44" name="Shape 42"/>
+          <p:cNvSpPr/>
+          <p:nvPr/>
+        </p:nvSpPr>
+        <p:spPr>
+          <a:xfrm>
+            <a:off x="7443216" y="2395728"/>
+            <a:ext cx="420624" cy="237744"/>
+          </a:xfrm>
+          <a:prstGeom prst="roundRect">
+            <a:avLst>
+              <a:gd name="adj" fmla="val 15385"/>
+            </a:avLst>
+          </a:prstGeom>
+          <a:solidFill>
+            <a:srgbClr val="FFF3EE"/>
+          </a:solidFill>
+          <a:ln/>
+        </p:spPr>
+      </p:sp>
+      <p:sp>
+        <p:nvSpPr>
+          <p:cNvPr id="45" name="Text 43"/>
+          <p:cNvSpPr/>
+          <p:nvPr/>
+        </p:nvSpPr>
+        <p:spPr>
+          <a:xfrm>
+            <a:off x="7443216" y="2395728"/>
+            <a:ext cx="420624" cy="237744"/>
+          </a:xfrm>
+          <a:prstGeom prst="rect">
+            <a:avLst/>
+          </a:prstGeom>
+          <a:noFill/>
+          <a:ln/>
+        </p:spPr>
+        <p:txBody>
+          <a:bodyPr wrap="square" lIns="0" tIns="0" rIns="0" bIns="0" rtlCol="0" anchor="ctr"/>
+          <a:lstStyle/>
+          <a:p>
+            <a:pPr algn="ctr" indent="0" marL="0">
+              <a:buNone/>
+            </a:pPr>
+            <a:r>
+              <a:rPr lang="en-US" sz="750" dirty="0">
+                <a:solidFill>
+                  <a:srgbClr val="EE5A29"/>
+                </a:solidFill>
+                <a:latin typeface="Calibri" pitchFamily="34" charset="0"/>
+                <a:ea typeface="Calibri" pitchFamily="34" charset="-122"/>
+                <a:cs typeface="Calibri" pitchFamily="34" charset="-120"/>
+              </a:rPr>
+              <a:t>Tool 1</a:t>
+            </a:r>
+            <a:endParaRPr lang="en-US" sz="750" dirty="0"/>
+          </a:p>
+        </p:txBody>
+      </p:sp>
+      <p:sp>
+        <p:nvSpPr>
+          <p:cNvPr id="46" name="Shape 44"/>
+          <p:cNvSpPr/>
+          <p:nvPr/>
+        </p:nvSpPr>
+        <p:spPr>
+          <a:xfrm>
+            <a:off x="7936992" y="2395728"/>
+            <a:ext cx="420624" cy="237744"/>
+          </a:xfrm>
+          <a:prstGeom prst="roundRect">
+            <a:avLst>
+              <a:gd name="adj" fmla="val 15385"/>
+            </a:avLst>
+          </a:prstGeom>
+          <a:solidFill>
+            <a:srgbClr val="FFF3EE"/>
+          </a:solidFill>
+          <a:ln/>
+        </p:spPr>
+      </p:sp>
+      <p:sp>
+        <p:nvSpPr>
+          <p:cNvPr id="47" name="Text 45"/>
+          <p:cNvSpPr/>
+          <p:nvPr/>
+        </p:nvSpPr>
+        <p:spPr>
+          <a:xfrm>
+            <a:off x="7936992" y="2395728"/>
+            <a:ext cx="420624" cy="237744"/>
+          </a:xfrm>
+          <a:prstGeom prst="rect">
+            <a:avLst/>
+          </a:prstGeom>
+          <a:noFill/>
+          <a:ln/>
+        </p:spPr>
+        <p:txBody>
+          <a:bodyPr wrap="square" lIns="0" tIns="0" rIns="0" bIns="0" rtlCol="0" anchor="ctr"/>
+          <a:lstStyle/>
+          <a:p>
+            <a:pPr algn="ctr" indent="0" marL="0">
+              <a:buNone/>
+            </a:pPr>
+            <a:r>
+              <a:rPr lang="en-US" sz="750" dirty="0">
+                <a:solidFill>
+                  <a:srgbClr val="EE5A29"/>
+                </a:solidFill>
+                <a:latin typeface="Calibri" pitchFamily="34" charset="0"/>
+                <a:ea typeface="Calibri" pitchFamily="34" charset="-122"/>
+                <a:cs typeface="Calibri" pitchFamily="34" charset="-120"/>
+              </a:rPr>
+              <a:t>Tool 2</a:t>
+            </a:r>
+            <a:endParaRPr lang="en-US" sz="750" dirty="0"/>
+          </a:p>
+        </p:txBody>
+      </p:sp>
+      <p:sp>
+        <p:nvSpPr>
+          <p:cNvPr id="48" name="Shape 46"/>
+          <p:cNvSpPr/>
+          <p:nvPr/>
+        </p:nvSpPr>
+        <p:spPr>
+          <a:xfrm>
+            <a:off x="5303520" y="2807208"/>
+            <a:ext cx="786384" cy="310896"/>
+          </a:xfrm>
+          <a:prstGeom prst="roundRect">
+            <a:avLst>
+              <a:gd name="adj" fmla="val 17647"/>
+            </a:avLst>
+          </a:prstGeom>
+          <a:solidFill>
+            <a:srgbClr val="15154A"/>
+          </a:solidFill>
+          <a:ln/>
+        </p:spPr>
+      </p:sp>
+      <p:sp>
+        <p:nvSpPr>
+          <p:cNvPr id="49" name="Text 47"/>
+          <p:cNvSpPr/>
+          <p:nvPr/>
+        </p:nvSpPr>
+        <p:spPr>
+          <a:xfrm>
+            <a:off x="5303520" y="2807208"/>
+            <a:ext cx="786384" cy="310896"/>
+          </a:xfrm>
+          <a:prstGeom prst="rect">
+            <a:avLst/>
+          </a:prstGeom>
+          <a:noFill/>
+          <a:ln/>
+        </p:spPr>
+        <p:txBody>
+          <a:bodyPr wrap="square" lIns="0" tIns="0" rIns="0" bIns="0" rtlCol="0" anchor="ctr"/>
+          <a:lstStyle/>
+          <a:p>
+            <a:pPr algn="ctr" indent="0" marL="0">
+              <a:buNone/>
+            </a:pPr>
+            <a:r>
+              <a:rPr lang="en-US" sz="900" b="1" dirty="0">
+                <a:solidFill>
+                  <a:srgbClr val="FFFFFF"/>
+                </a:solidFill>
+                <a:latin typeface="Calibri" pitchFamily="34" charset="0"/>
+                <a:ea typeface="Calibri" pitchFamily="34" charset="-122"/>
+                <a:cs typeface="Calibri" pitchFamily="34" charset="-120"/>
+              </a:rPr>
+              <a:t>Task 1</a:t>
+            </a:r>
+            <a:endParaRPr lang="en-US" sz="900" dirty="0"/>
+          </a:p>
+        </p:txBody>
+      </p:sp>
+      <p:sp>
+        <p:nvSpPr>
+          <p:cNvPr id="50" name="Text 48"/>
+          <p:cNvSpPr/>
+          <p:nvPr/>
+        </p:nvSpPr>
+        <p:spPr>
+          <a:xfrm>
+            <a:off x="6089904" y="2807208"/>
+            <a:ext cx="256032" cy="310896"/>
+          </a:xfrm>
+          <a:prstGeom prst="rect">
+            <a:avLst/>
+          </a:prstGeom>
+          <a:noFill/>
+          <a:ln/>
+        </p:spPr>
+        <p:txBody>
+          <a:bodyPr wrap="square" lIns="0" tIns="0" rIns="0" bIns="0" rtlCol="0" anchor="ctr"/>
+          <a:lstStyle/>
+          <a:p>
+            <a:pPr algn="ctr" indent="0" marL="0">
+              <a:buNone/>
+            </a:pPr>
+            <a:r>
+              <a:rPr lang="en-US" sz="1000" b="1" dirty="0">
+                <a:solidFill>
+                  <a:srgbClr val="EE5A29"/>
+                </a:solidFill>
+                <a:latin typeface="Arial" pitchFamily="34" charset="0"/>
+                <a:ea typeface="Arial" pitchFamily="34" charset="-122"/>
+                <a:cs typeface="Arial" pitchFamily="34" charset="-120"/>
+              </a:rPr>
+              <a:t>→</a:t>
+            </a:r>
+            <a:endParaRPr lang="en-US" sz="1000" dirty="0"/>
+          </a:p>
+        </p:txBody>
+      </p:sp>
+      <p:sp>
+        <p:nvSpPr>
+          <p:cNvPr id="51" name="Shape 49"/>
+          <p:cNvSpPr/>
+          <p:nvPr/>
+        </p:nvSpPr>
+        <p:spPr>
+          <a:xfrm>
+            <a:off x="6345936" y="2807208"/>
+            <a:ext cx="786384" cy="310896"/>
+          </a:xfrm>
+          <a:prstGeom prst="roundRect">
+            <a:avLst>
+              <a:gd name="adj" fmla="val 17647"/>
+            </a:avLst>
+          </a:prstGeom>
+          <a:solidFill>
+            <a:srgbClr val="15154A"/>
+          </a:solidFill>
+          <a:ln/>
+        </p:spPr>
+      </p:sp>
+      <p:sp>
+        <p:nvSpPr>
+          <p:cNvPr id="52" name="Text 50"/>
+          <p:cNvSpPr/>
+          <p:nvPr/>
+        </p:nvSpPr>
+        <p:spPr>
+          <a:xfrm>
+            <a:off x="6345936" y="2807208"/>
+            <a:ext cx="786384" cy="310896"/>
+          </a:xfrm>
+          <a:prstGeom prst="rect">
+            <a:avLst/>
+          </a:prstGeom>
+          <a:noFill/>
+          <a:ln/>
+        </p:spPr>
+        <p:txBody>
+          <a:bodyPr wrap="square" lIns="0" tIns="0" rIns="0" bIns="0" rtlCol="0" anchor="ctr"/>
+          <a:lstStyle/>
+          <a:p>
+            <a:pPr algn="ctr" indent="0" marL="0">
+              <a:buNone/>
+            </a:pPr>
+            <a:r>
+              <a:rPr lang="en-US" sz="900" b="1" dirty="0">
+                <a:solidFill>
+                  <a:srgbClr val="FFFFFF"/>
+                </a:solidFill>
+                <a:latin typeface="Calibri" pitchFamily="34" charset="0"/>
+                <a:ea typeface="Calibri" pitchFamily="34" charset="-122"/>
+                <a:cs typeface="Calibri" pitchFamily="34" charset="-120"/>
+              </a:rPr>
+              <a:t>Task 2</a:t>
+            </a:r>
+            <a:endParaRPr lang="en-US" sz="900" dirty="0"/>
+          </a:p>
+        </p:txBody>
+      </p:sp>
+      <p:sp>
+        <p:nvSpPr>
+          <p:cNvPr id="53" name="Text 51"/>
+          <p:cNvSpPr/>
+          <p:nvPr/>
+        </p:nvSpPr>
+        <p:spPr>
+          <a:xfrm>
+            <a:off x="7132320" y="2807208"/>
+            <a:ext cx="256032" cy="310896"/>
+          </a:xfrm>
+          <a:prstGeom prst="rect">
+            <a:avLst/>
+          </a:prstGeom>
+          <a:noFill/>
+          <a:ln/>
+        </p:spPr>
+        <p:txBody>
+          <a:bodyPr wrap="square" lIns="0" tIns="0" rIns="0" bIns="0" rtlCol="0" anchor="ctr"/>
+          <a:lstStyle/>
+          <a:p>
+            <a:pPr algn="ctr" indent="0" marL="0">
+              <a:buNone/>
+            </a:pPr>
+            <a:r>
+              <a:rPr lang="en-US" sz="1000" b="1" dirty="0">
+                <a:solidFill>
+                  <a:srgbClr val="EE5A29"/>
+                </a:solidFill>
+                <a:latin typeface="Arial" pitchFamily="34" charset="0"/>
+                <a:ea typeface="Arial" pitchFamily="34" charset="-122"/>
+                <a:cs typeface="Arial" pitchFamily="34" charset="-120"/>
+              </a:rPr>
+              <a:t>→</a:t>
+            </a:r>
+            <a:endParaRPr lang="en-US" sz="1000" dirty="0"/>
+          </a:p>
+        </p:txBody>
+      </p:sp>
+      <p:sp>
+        <p:nvSpPr>
+          <p:cNvPr id="54" name="Shape 52"/>
+          <p:cNvSpPr/>
+          <p:nvPr/>
+        </p:nvSpPr>
+        <p:spPr>
+          <a:xfrm>
+            <a:off x="7388352" y="2807208"/>
+            <a:ext cx="786384" cy="310896"/>
+          </a:xfrm>
+          <a:prstGeom prst="roundRect">
+            <a:avLst>
+              <a:gd name="adj" fmla="val 17647"/>
+            </a:avLst>
+          </a:prstGeom>
+          <a:solidFill>
+            <a:srgbClr val="15154A"/>
+          </a:solidFill>
+          <a:ln/>
+        </p:spPr>
+      </p:sp>
+      <p:sp>
+        <p:nvSpPr>
+          <p:cNvPr id="55" name="Text 53"/>
+          <p:cNvSpPr/>
+          <p:nvPr/>
+        </p:nvSpPr>
+        <p:spPr>
+          <a:xfrm>
+            <a:off x="7388352" y="2807208"/>
+            <a:ext cx="786384" cy="310896"/>
+          </a:xfrm>
+          <a:prstGeom prst="rect">
+            <a:avLst/>
+          </a:prstGeom>
+          <a:noFill/>
+          <a:ln/>
+        </p:spPr>
+        <p:txBody>
+          <a:bodyPr wrap="square" lIns="0" tIns="0" rIns="0" bIns="0" rtlCol="0" anchor="ctr"/>
+          <a:lstStyle/>
+          <a:p>
+            <a:pPr algn="ctr" indent="0" marL="0">
+              <a:buNone/>
+            </a:pPr>
+            <a:r>
+              <a:rPr lang="en-US" sz="900" b="1" dirty="0">
+                <a:solidFill>
+                  <a:srgbClr val="FFFFFF"/>
+                </a:solidFill>
+                <a:latin typeface="Calibri" pitchFamily="34" charset="0"/>
+                <a:ea typeface="Calibri" pitchFamily="34" charset="-122"/>
+                <a:cs typeface="Calibri" pitchFamily="34" charset="-120"/>
+              </a:rPr>
+              <a:t>Task 3</a:t>
+            </a:r>
+            <a:endParaRPr lang="en-US" sz="900" dirty="0"/>
+          </a:p>
+        </p:txBody>
+      </p:sp>
+      <p:sp>
+        <p:nvSpPr>
+          <p:cNvPr id="56" name="Shape 54"/>
+          <p:cNvSpPr/>
+          <p:nvPr/>
+        </p:nvSpPr>
+        <p:spPr>
+          <a:xfrm>
+            <a:off x="5230368" y="3310128"/>
+            <a:ext cx="3163824" cy="329184"/>
+          </a:xfrm>
+          <a:prstGeom prst="roundRect">
+            <a:avLst>
+              <a:gd name="adj" fmla="val 19444"/>
+            </a:avLst>
+          </a:prstGeom>
+          <a:solidFill>
+            <a:srgbClr val="23236B">
+              <a:alpha val="70000"/>
+            </a:srgbClr>
+          </a:solidFill>
+          <a:ln/>
+        </p:spPr>
+      </p:sp>
+      <p:sp>
+        <p:nvSpPr>
+          <p:cNvPr id="57" name="Text 55"/>
+          <p:cNvSpPr/>
+          <p:nvPr/>
+        </p:nvSpPr>
+        <p:spPr>
+          <a:xfrm>
+            <a:off x="5230368" y="3310128"/>
+            <a:ext cx="3163824" cy="329184"/>
+          </a:xfrm>
+          <a:prstGeom prst="rect">
+            <a:avLst/>
+          </a:prstGeom>
+          <a:noFill/>
+          <a:ln/>
+        </p:spPr>
+        <p:txBody>
+          <a:bodyPr wrap="square" lIns="0" tIns="0" rIns="0" bIns="0" rtlCol="0" anchor="ctr"/>
+          <a:lstStyle/>
+          <a:p>
+            <a:pPr algn="ctr" indent="0" marL="0">
+              <a:buNone/>
+            </a:pPr>
+            <a:r>
+              <a:rPr lang="en-US" sz="1000" b="1" dirty="0">
+                <a:solidFill>
+                  <a:srgbClr val="FFFFFF"/>
+                </a:solidFill>
+                <a:latin typeface="Calibri" pitchFamily="34" charset="0"/>
+                <a:ea typeface="Calibri" pitchFamily="34" charset="-122"/>
+                <a:cs typeface="Calibri" pitchFamily="34" charset="-120"/>
+              </a:rPr>
+              <a:t>Test  |  Deploy  |  Observe</a:t>
+            </a:r>
+            <a:endParaRPr lang="en-US" sz="1000" dirty="0"/>
+          </a:p>
+        </p:txBody>
+      </p:sp>
+      <p:sp>
+        <p:nvSpPr>
+          <p:cNvPr id="58" name="Shape 56"/>
+          <p:cNvSpPr/>
+          <p:nvPr/>
+        </p:nvSpPr>
+        <p:spPr>
+          <a:xfrm>
+            <a:off x="5230368" y="3785616"/>
+            <a:ext cx="1490472" cy="347472"/>
+          </a:xfrm>
+          <a:prstGeom prst="roundRect">
+            <a:avLst>
+              <a:gd name="adj" fmla="val 18421"/>
+            </a:avLst>
+          </a:prstGeom>
+          <a:solidFill>
+            <a:srgbClr val="E9E9FE"/>
+          </a:solidFill>
+          <a:ln/>
+        </p:spPr>
+      </p:sp>
+      <p:sp>
+        <p:nvSpPr>
+          <p:cNvPr id="59" name="Text 57"/>
+          <p:cNvSpPr/>
+          <p:nvPr/>
+        </p:nvSpPr>
+        <p:spPr>
+          <a:xfrm>
+            <a:off x="5230368" y="3785616"/>
+            <a:ext cx="1490472" cy="347472"/>
+          </a:xfrm>
+          <a:prstGeom prst="rect">
+            <a:avLst/>
+          </a:prstGeom>
+          <a:noFill/>
+          <a:ln/>
+        </p:spPr>
+        <p:txBody>
+          <a:bodyPr wrap="square" lIns="0" tIns="0" rIns="0" bIns="0" rtlCol="0" anchor="ctr"/>
+          <a:lstStyle/>
+          <a:p>
+            <a:pPr algn="ctr" indent="0" marL="0">
+              <a:buNone/>
+            </a:pPr>
+            <a:r>
+              <a:rPr lang="en-US" sz="800" b="1" dirty="0">
+                <a:solidFill>
+                  <a:srgbClr val="4F4FF5"/>
+                </a:solidFill>
+                <a:latin typeface="Calibri" pitchFamily="34" charset="0"/>
+                <a:ea typeface="Calibri" pitchFamily="34" charset="-122"/>
+                <a:cs typeface="Calibri" pitchFamily="34" charset="-120"/>
+              </a:rPr>
+              <a:t>Private Cloud GA (PVC 1.5.5-SP3)</a:t>
+            </a:r>
+            <a:endParaRPr lang="en-US" sz="800" dirty="0"/>
+          </a:p>
+        </p:txBody>
+      </p:sp>
+      <p:sp>
+        <p:nvSpPr>
+          <p:cNvPr id="60" name="Shape 58"/>
+          <p:cNvSpPr/>
+          <p:nvPr/>
+        </p:nvSpPr>
+        <p:spPr>
+          <a:xfrm>
+            <a:off x="6885432" y="3785616"/>
+            <a:ext cx="1490472" cy="347472"/>
+          </a:xfrm>
+          <a:prstGeom prst="roundRect">
+            <a:avLst>
+              <a:gd name="adj" fmla="val 18421"/>
+            </a:avLst>
+          </a:prstGeom>
+          <a:solidFill>
+            <a:srgbClr val="FFF3EE"/>
+          </a:solidFill>
+          <a:ln/>
+        </p:spPr>
+      </p:sp>
+      <p:sp>
+        <p:nvSpPr>
+          <p:cNvPr id="61" name="Text 59"/>
+          <p:cNvSpPr/>
+          <p:nvPr/>
+        </p:nvSpPr>
+        <p:spPr>
+          <a:xfrm>
+            <a:off x="6885432" y="3785616"/>
+            <a:ext cx="1490472" cy="347472"/>
+          </a:xfrm>
+          <a:prstGeom prst="rect">
+            <a:avLst/>
+          </a:prstGeom>
+          <a:noFill/>
+          <a:ln/>
+        </p:spPr>
+        <p:txBody>
+          <a:bodyPr wrap="square" lIns="0" tIns="0" rIns="0" bIns="0" rtlCol="0" anchor="ctr"/>
+          <a:lstStyle/>
+          <a:p>
+            <a:pPr algn="ctr" indent="0" marL="0">
+              <a:buNone/>
+            </a:pPr>
+            <a:r>
+              <a:rPr lang="en-US" sz="800" b="1" dirty="0">
+                <a:solidFill>
+                  <a:srgbClr val="EE5A29"/>
+                </a:solidFill>
+                <a:latin typeface="Calibri" pitchFamily="34" charset="0"/>
+                <a:ea typeface="Calibri" pitchFamily="34" charset="-122"/>
+                <a:cs typeface="Calibri" pitchFamily="34" charset="-120"/>
+              </a:rPr>
+              <a:t>Public Cloud (AWS, Azure — TP)</a:t>
+            </a:r>
+            <a:endParaRPr lang="en-US" sz="800" dirty="0"/>
+          </a:p>
+        </p:txBody>
+      </p:sp>
+      <p:sp>
+        <p:nvSpPr>
+          <p:cNvPr id="62" name="Text 60"/>
+          <p:cNvSpPr/>
+          <p:nvPr/>
+        </p:nvSpPr>
+        <p:spPr>
+          <a:xfrm>
+            <a:off x="566928" y="4759452"/>
+            <a:ext cx="6858000" cy="256032"/>
+          </a:xfrm>
+          <a:prstGeom prst="rect">
+            <a:avLst/>
+          </a:prstGeom>
+          <a:noFill/>
+          <a:ln/>
+        </p:spPr>
+        <p:txBody>
+          <a:bodyPr wrap="square" lIns="0" tIns="0" rIns="0" bIns="0" rtlCol="0" anchor="ctr"/>
+          <a:lstStyle/>
+          <a:p>
+            <a:pPr indent="0" marL="0">
+              <a:buNone/>
+            </a:pPr>
+            <a:r>
+              <a:rPr lang="en-US" sz="800" dirty="0">
+                <a:solidFill>
+                  <a:srgbClr val="9A9AB4"/>
+                </a:solidFill>
+                <a:latin typeface="Calibri" pitchFamily="34" charset="0"/>
+                <a:ea typeface="Calibri" pitchFamily="34" charset="-122"/>
+                <a:cs typeface="Calibri" pitchFamily="34" charset="-120"/>
+              </a:rPr>
+              <a:t>©2026 Cloudera, Inc. All Rights Reserved. · Agent Studio v3.0.0-b28 (PVC) / v2.3.0-b40 (Public Cloud).</a:t>
+            </a:r>
+            <a:endParaRPr lang="en-US" sz="800" dirty="0"/>
+          </a:p>
+        </p:txBody>
+      </p:sp>
+      <p:sp>
+        <p:nvSpPr>
+          <p:cNvPr id="63" name="Text 61"/>
+          <p:cNvSpPr/>
+          <p:nvPr/>
+        </p:nvSpPr>
+        <p:spPr>
+          <a:xfrm>
+            <a:off x="7955280" y="4759452"/>
+            <a:ext cx="640080" cy="256032"/>
+          </a:xfrm>
+          <a:prstGeom prst="rect">
+            <a:avLst/>
+          </a:prstGeom>
+          <a:noFill/>
+          <a:ln/>
+        </p:spPr>
+        <p:txBody>
+          <a:bodyPr wrap="square" lIns="0" tIns="0" rIns="0" bIns="0" rtlCol="0" anchor="ctr"/>
+          <a:lstStyle/>
+          <a:p>
+            <a:pPr algn="r" indent="0" marL="0">
+              <a:buNone/>
+            </a:pPr>
+            <a:r>
+              <a:rPr lang="en-US" sz="800" dirty="0">
+                <a:solidFill>
+                  <a:srgbClr val="9A9AB4"/>
+                </a:solidFill>
+                <a:latin typeface="Calibri" pitchFamily="34" charset="0"/>
+                <a:ea typeface="Calibri" pitchFamily="34" charset="-122"/>
+                <a:cs typeface="Calibri" pitchFamily="34" charset="-120"/>
+              </a:rPr>
+              <a:t>21 / 22</a:t>
+            </a:r>
+            <a:endParaRPr lang="en-US" sz="800" dirty="0"/>
+          </a:p>
+        </p:txBody>
+      </p:sp>
+    </p:spTree>
+  </p:cSld>
+  <p:clrMapOvr>
+    <a:masterClrMapping/>
+  </p:clrMapOvr>
+</p:sld>
+</file>
+
+<file path=ppt/slides/slide22.xml><?xml version="1.0" encoding="utf-8"?>
+<p:sld xmlns:a="http://schemas.openxmlformats.org/drawingml/2006/main" xmlns:r="http://schemas.openxmlformats.org/officeDocument/2006/relationships" xmlns:p="http://schemas.openxmlformats.org/presentationml/2006/main">
+  <p:cSld name="Slide 22">
+    <p:bg>
+      <p:bgPr>
+        <a:solidFill>
+          <a:srgbClr val="F6F6FB"/>
+        </a:solidFill>
+      </p:bgPr>
+    </p:bg>
+    <p:spTree>
+      <p:nvGrpSpPr>
+        <p:cNvPr id="1" name=""/>
+        <p:cNvGrpSpPr/>
+        <p:nvPr/>
+      </p:nvGrpSpPr>
+      <p:grpSpPr>
+        <a:xfrm>
+          <a:off x="0" y="0"/>
+          <a:ext cx="0" cy="0"/>
+          <a:chOff x="0" y="0"/>
+          <a:chExt cx="0" cy="0"/>
+        </a:xfrm>
+      </p:grpSpPr>
+      <p:sp>
+        <p:nvSpPr>
+          <p:cNvPr id="2" name="Text 0"/>
+          <p:cNvSpPr/>
+          <p:nvPr/>
+        </p:nvSpPr>
+        <p:spPr>
+          <a:xfrm>
+            <a:off x="6858000" y="292608"/>
+            <a:ext cx="1737360" cy="292608"/>
+          </a:xfrm>
+          <a:prstGeom prst="rect">
+            <a:avLst/>
+          </a:prstGeom>
+          <a:noFill/>
+          <a:ln/>
+        </p:spPr>
+        <p:txBody>
+          <a:bodyPr wrap="square" lIns="0" tIns="0" rIns="0" bIns="0" rtlCol="0" anchor="ctr"/>
+          <a:lstStyle/>
+          <a:p>
+            <a:pPr algn="r" indent="0" marL="0">
+              <a:buNone/>
+            </a:pPr>
+            <a:r>
+              <a:rPr lang="en-US" sz="1300" b="1" spc="300" kern="0" dirty="0">
+                <a:solidFill>
+                  <a:srgbClr val="EE5A29"/>
+                </a:solidFill>
+                <a:latin typeface="Arial" pitchFamily="34" charset="0"/>
+                <a:ea typeface="Arial" pitchFamily="34" charset="-122"/>
+                <a:cs typeface="Arial" pitchFamily="34" charset="-120"/>
+              </a:rPr>
+              <a:t>CLOUD</a:t>
+            </a:r>
+            <a:pPr algn="r" indent="0" marL="0">
+              <a:buNone/>
+            </a:pPr>
+            <a:r>
+              <a:rPr lang="en-US" sz="1300" b="1" spc="300" kern="0" dirty="0">
+                <a:solidFill>
+                  <a:srgbClr val="EE5A29"/>
+                </a:solidFill>
+                <a:latin typeface="Arial" pitchFamily="34" charset="0"/>
+                <a:ea typeface="Arial" pitchFamily="34" charset="-122"/>
+                <a:cs typeface="Arial" pitchFamily="34" charset="-120"/>
+              </a:rPr>
+              <a:t>E</a:t>
+            </a:r>
+            <a:pPr algn="r" indent="0" marL="0">
+              <a:buNone/>
+            </a:pPr>
+            <a:r>
+              <a:rPr lang="en-US" sz="1300" b="1" spc="300" kern="0" dirty="0">
+                <a:solidFill>
+                  <a:srgbClr val="EE5A29"/>
+                </a:solidFill>
+                <a:latin typeface="Arial" pitchFamily="34" charset="0"/>
+                <a:ea typeface="Arial" pitchFamily="34" charset="-122"/>
+                <a:cs typeface="Arial" pitchFamily="34" charset="-120"/>
+              </a:rPr>
+              <a:t>RA</a:t>
+            </a:r>
+            <a:endParaRPr lang="en-US" sz="1300" dirty="0"/>
+          </a:p>
+        </p:txBody>
+      </p:sp>
+      <p:sp>
+        <p:nvSpPr>
+          <p:cNvPr id="3" name="Shape 1"/>
+          <p:cNvSpPr/>
+          <p:nvPr/>
+        </p:nvSpPr>
+        <p:spPr>
+          <a:xfrm>
+            <a:off x="566928" y="420624"/>
+            <a:ext cx="274320" cy="41148"/>
+          </a:xfrm>
+          <a:prstGeom prst="rect">
+            <a:avLst/>
+          </a:prstGeom>
+          <a:solidFill>
+            <a:srgbClr val="EE5A29"/>
+          </a:solidFill>
+          <a:ln/>
+        </p:spPr>
+      </p:sp>
+      <p:sp>
+        <p:nvSpPr>
+          <p:cNvPr id="4" name="Text 2"/>
+          <p:cNvSpPr/>
+          <p:nvPr/>
+        </p:nvSpPr>
+        <p:spPr>
+          <a:xfrm>
+            <a:off x="932688" y="274320"/>
+            <a:ext cx="6400800" cy="274320"/>
+          </a:xfrm>
+          <a:prstGeom prst="rect">
+            <a:avLst/>
+          </a:prstGeom>
+          <a:noFill/>
+          <a:ln/>
+        </p:spPr>
+        <p:txBody>
+          <a:bodyPr wrap="square" lIns="0" tIns="0" rIns="0" bIns="0" rtlCol="0" anchor="ctr"/>
+          <a:lstStyle/>
+          <a:p>
+            <a:pPr indent="0" marL="0">
+              <a:buNone/>
+            </a:pPr>
+            <a:r>
+              <a:rPr lang="en-US" sz="1050" b="1" spc="200" kern="0" dirty="0">
+                <a:solidFill>
+                  <a:srgbClr val="EE5A29"/>
+                </a:solidFill>
+                <a:latin typeface="Calibri" pitchFamily="34" charset="0"/>
+                <a:ea typeface="Calibri" pitchFamily="34" charset="-122"/>
+                <a:cs typeface="Calibri" pitchFamily="34" charset="-120"/>
+              </a:rPr>
+              <a:t>FROM THEORY TO PRODUCT</a:t>
+            </a:r>
+            <a:endParaRPr lang="en-US" sz="1050" dirty="0"/>
+          </a:p>
+        </p:txBody>
+      </p:sp>
+      <p:sp>
+        <p:nvSpPr>
+          <p:cNvPr id="5" name="Text 3"/>
+          <p:cNvSpPr/>
+          <p:nvPr/>
+        </p:nvSpPr>
+        <p:spPr>
+          <a:xfrm>
+            <a:off x="566928" y="566928"/>
+            <a:ext cx="8046720" cy="658368"/>
+          </a:xfrm>
+          <a:prstGeom prst="rect">
+            <a:avLst/>
+          </a:prstGeom>
+          <a:noFill/>
+          <a:ln/>
+        </p:spPr>
+        <p:txBody>
+          <a:bodyPr wrap="square" lIns="0" tIns="0" rIns="0" bIns="0" rtlCol="0" anchor="ctr"/>
+          <a:lstStyle/>
+          <a:p>
+            <a:pPr indent="0" marL="0">
+              <a:buNone/>
+            </a:pPr>
+            <a:r>
+              <a:rPr lang="en-US" sz="2700" b="1" dirty="0">
+                <a:solidFill>
+                  <a:srgbClr val="15154A"/>
+                </a:solidFill>
+                <a:latin typeface="Arial" pitchFamily="34" charset="0"/>
+                <a:ea typeface="Arial" pitchFamily="34" charset="-122"/>
+                <a:cs typeface="Arial" pitchFamily="34" charset="-120"/>
+              </a:rPr>
+              <a:t>Agent Studio — The Harness Pillars in Practice</a:t>
+            </a:r>
+            <a:endParaRPr lang="en-US" sz="2700" dirty="0"/>
+          </a:p>
+        </p:txBody>
+      </p:sp>
+      <p:graphicFrame>
+        <p:nvGraphicFramePr>
+          <p:cNvPr id="23" name="Table 0"/>
+          <p:cNvGraphicFramePr>
+            <a:graphicFrameLocks noGrp="1"/>
+          </p:cNvGraphicFramePr>
+          <p:nvPr>
+            <p:extLst>
+              <p:ext uri="{D42A27DB-BD31-4B8C-83A1-F6EECF244321}">
+                <p14:modId xmlns:p14="http://schemas.microsoft.com/office/powerpoint/2010/main" val="1579011935"/>
+              </p:ext>
+            </p:extLst>
+          </p:nvPr>
+        </p:nvGraphicFramePr>
+        <p:xfrm>
+          <a:off x="566928" y="1389888"/>
+          <a:ext cx="8010144" cy="914400"/>
+        </p:xfrm>
+        <a:graphic>
+          <a:graphicData uri="http://schemas.openxmlformats.org/drawingml/2006/table">
+            <a:tbl>
+              <a:tblPr/>
+              <a:tblGrid>
+                <a:gridCol w="2194560"/>
+                <a:gridCol w="2377440"/>
+                <a:gridCol w="3438144"/>
+              </a:tblGrid>
+              <a:tr h="292608">
+                <a:tc>
+                  <a:txBody>
+                    <a:bodyPr/>
+                    <a:lstStyle/>
+                    <a:p>
+                      <a:pPr indent="0" marL="0">
+                        <a:buNone/>
+                      </a:pPr>
+                      <a:r>
+                        <a:rPr lang="en-US" sz="1000" b="1" dirty="0">
+                          <a:solidFill>
+                            <a:srgbClr val="FFFFFF"/>
+                          </a:solidFill>
+                          <a:latin typeface="Arial" pitchFamily="34" charset="0"/>
+                          <a:ea typeface="Arial" pitchFamily="34" charset="-122"/>
+                          <a:cs typeface="Arial" pitchFamily="34" charset="-120"/>
+                        </a:rPr>
+                        <a:t>Harness Pillar</a:t>
+                      </a:r>
+                      <a:endParaRPr lang="en-US" sz="1000" dirty="0">
+                        <a:latin typeface="Arial" charset="0"/>
+                        <a:ea typeface="Arial" charset="0"/>
+                        <a:cs typeface="Arial" charset="0"/>
+                      </a:endParaRPr>
+                    </a:p>
+                  </a:txBody>
+                  <a:tcPr marL="50800" marR="50800" marT="50800" marB="50800" anchor="ctr">
+                    <a:lnL w="6350" cap="flat" cmpd="sng" algn="ctr">
+                      <a:solidFill>
+                        <a:srgbClr val="E2E2EC"/>
+                      </a:solidFill>
+                      <a:prstDash val="solid"/>
+                      <a:round/>
+                      <a:headEnd type="none" w="med" len="med"/>
+                      <a:tailEnd type="none" w="med" len="med"/>
+                    </a:lnL>
+                    <a:lnR w="6350" cap="flat" cmpd="sng" algn="ctr">
+                      <a:solidFill>
+                        <a:srgbClr val="E2E2EC"/>
+                      </a:solidFill>
+                      <a:prstDash val="solid"/>
+                      <a:round/>
+                      <a:headEnd type="none" w="med" len="med"/>
+                      <a:tailEnd type="none" w="med" len="med"/>
+                    </a:lnR>
+                    <a:lnT w="6350" cap="flat" cmpd="sng" algn="ctr">
+                      <a:solidFill>
+                        <a:srgbClr val="E2E2EC"/>
+                      </a:solidFill>
+                      <a:prstDash val="solid"/>
+                      <a:round/>
+                      <a:headEnd type="none" w="med" len="med"/>
+                      <a:tailEnd type="none" w="med" len="med"/>
+                    </a:lnT>
+                    <a:lnB w="6350" cap="flat" cmpd="sng" algn="ctr">
+                      <a:solidFill>
+                        <a:srgbClr val="E2E2EC"/>
+                      </a:solidFill>
+                      <a:prstDash val="solid"/>
+                      <a:round/>
+                      <a:headEnd type="none" w="med" len="med"/>
+                      <a:tailEnd type="none" w="med" len="med"/>
+                    </a:lnB>
+                    <a:solidFill>
+                      <a:srgbClr val="15154A"/>
+                    </a:solidFill>
+                  </a:tcPr>
+                </a:tc>
+                <a:tc>
+                  <a:txBody>
+                    <a:bodyPr/>
+                    <a:lstStyle/>
+                    <a:p>
+                      <a:pPr indent="0" marL="0">
+                        <a:buNone/>
+                      </a:pPr>
+                      <a:r>
+                        <a:rPr lang="en-US" sz="1000" b="1" dirty="0">
+                          <a:solidFill>
+                            <a:srgbClr val="FFFFFF"/>
+                          </a:solidFill>
+                          <a:latin typeface="Arial" pitchFamily="34" charset="0"/>
+                          <a:ea typeface="Arial" pitchFamily="34" charset="-122"/>
+                          <a:cs typeface="Arial" pitchFamily="34" charset="-120"/>
+                        </a:rPr>
+                        <a:t>What it means</a:t>
+                      </a:r>
+                      <a:endParaRPr lang="en-US" sz="1000" dirty="0">
+                        <a:latin typeface="Arial" charset="0"/>
+                        <a:ea typeface="Arial" charset="0"/>
+                        <a:cs typeface="Arial" charset="0"/>
+                      </a:endParaRPr>
+                    </a:p>
+                  </a:txBody>
+                  <a:tcPr marL="50800" marR="50800" marT="50800" marB="50800" anchor="ctr">
+                    <a:lnL w="6350" cap="flat" cmpd="sng" algn="ctr">
+                      <a:solidFill>
+                        <a:srgbClr val="E2E2EC"/>
+                      </a:solidFill>
+                      <a:prstDash val="solid"/>
+                      <a:round/>
+                      <a:headEnd type="none" w="med" len="med"/>
+                      <a:tailEnd type="none" w="med" len="med"/>
+                    </a:lnL>
+                    <a:lnR w="6350" cap="flat" cmpd="sng" algn="ctr">
+                      <a:solidFill>
+                        <a:srgbClr val="E2E2EC"/>
+                      </a:solidFill>
+                      <a:prstDash val="solid"/>
+                      <a:round/>
+                      <a:headEnd type="none" w="med" len="med"/>
+                      <a:tailEnd type="none" w="med" len="med"/>
+                    </a:lnR>
+                    <a:lnT w="6350" cap="flat" cmpd="sng" algn="ctr">
+                      <a:solidFill>
+                        <a:srgbClr val="E2E2EC"/>
+                      </a:solidFill>
+                      <a:prstDash val="solid"/>
+                      <a:round/>
+                      <a:headEnd type="none" w="med" len="med"/>
+                      <a:tailEnd type="none" w="med" len="med"/>
+                    </a:lnT>
+                    <a:lnB w="6350" cap="flat" cmpd="sng" algn="ctr">
+                      <a:solidFill>
+                        <a:srgbClr val="E2E2EC"/>
+                      </a:solidFill>
+                      <a:prstDash val="solid"/>
+                      <a:round/>
+                      <a:headEnd type="none" w="med" len="med"/>
+                      <a:tailEnd type="none" w="med" len="med"/>
+                    </a:lnB>
+                    <a:solidFill>
+                      <a:srgbClr val="15154A"/>
+                    </a:solidFill>
+                  </a:tcPr>
+                </a:tc>
+                <a:tc>
+                  <a:txBody>
+                    <a:bodyPr/>
+                    <a:lstStyle/>
+                    <a:p>
+                      <a:pPr indent="0" marL="0">
+                        <a:buNone/>
+                      </a:pPr>
+                      <a:r>
+                        <a:rPr lang="en-US" sz="1000" b="1" dirty="0">
+                          <a:solidFill>
+                            <a:srgbClr val="FFFFFF"/>
+                          </a:solidFill>
+                          <a:latin typeface="Arial" pitchFamily="34" charset="0"/>
+                          <a:ea typeface="Arial" pitchFamily="34" charset="-122"/>
+                          <a:cs typeface="Arial" pitchFamily="34" charset="-120"/>
+                        </a:rPr>
+                        <a:t>Agent Studio implementation</a:t>
+                      </a:r>
+                      <a:endParaRPr lang="en-US" sz="1000" dirty="0">
+                        <a:latin typeface="Arial" charset="0"/>
+                        <a:ea typeface="Arial" charset="0"/>
+                        <a:cs typeface="Arial" charset="0"/>
+                      </a:endParaRPr>
+                    </a:p>
+                  </a:txBody>
+                  <a:tcPr marL="50800" marR="50800" marT="50800" marB="50800" anchor="ctr">
+                    <a:lnL w="6350" cap="flat" cmpd="sng" algn="ctr">
+                      <a:solidFill>
+                        <a:srgbClr val="E2E2EC"/>
+                      </a:solidFill>
+                      <a:prstDash val="solid"/>
+                      <a:round/>
+                      <a:headEnd type="none" w="med" len="med"/>
+                      <a:tailEnd type="none" w="med" len="med"/>
+                    </a:lnL>
+                    <a:lnR w="6350" cap="flat" cmpd="sng" algn="ctr">
+                      <a:solidFill>
+                        <a:srgbClr val="E2E2EC"/>
+                      </a:solidFill>
+                      <a:prstDash val="solid"/>
+                      <a:round/>
+                      <a:headEnd type="none" w="med" len="med"/>
+                      <a:tailEnd type="none" w="med" len="med"/>
+                    </a:lnR>
+                    <a:lnT w="6350" cap="flat" cmpd="sng" algn="ctr">
+                      <a:solidFill>
+                        <a:srgbClr val="E2E2EC"/>
+                      </a:solidFill>
+                      <a:prstDash val="solid"/>
+                      <a:round/>
+                      <a:headEnd type="none" w="med" len="med"/>
+                      <a:tailEnd type="none" w="med" len="med"/>
+                    </a:lnT>
+                    <a:lnB w="6350" cap="flat" cmpd="sng" algn="ctr">
+                      <a:solidFill>
+                        <a:srgbClr val="E2E2EC"/>
+                      </a:solidFill>
+                      <a:prstDash val="solid"/>
+                      <a:round/>
+                      <a:headEnd type="none" w="med" len="med"/>
+                      <a:tailEnd type="none" w="med" len="med"/>
+                    </a:lnB>
+                    <a:solidFill>
+                      <a:srgbClr val="15154A"/>
+                    </a:solidFill>
+                  </a:tcPr>
+                </a:tc>
+              </a:tr>
+              <a:tr h="731520">
+                <a:tc>
+                  <a:txBody>
+                    <a:bodyPr/>
+                    <a:lstStyle/>
+                    <a:p>
+                      <a:pPr indent="0" marL="0">
+                        <a:buNone/>
+                      </a:pPr>
+                      <a:r>
+                        <a:rPr lang="en-US" sz="900" b="1" dirty="0">
+                          <a:solidFill>
+                            <a:srgbClr val="4F4FF5"/>
+                          </a:solidFill>
+                          <a:latin typeface="Calibri" pitchFamily="34" charset="0"/>
+                          <a:ea typeface="Calibri" pitchFamily="34" charset="-122"/>
+                          <a:cs typeface="Calibri" pitchFamily="34" charset="-120"/>
+                        </a:rPr>
+                        <a:t>Progressive Context Architecture</a:t>
+                      </a:r>
+                      <a:endParaRPr lang="en-US" sz="900" dirty="0">
+                        <a:latin typeface="Calibri" charset="0"/>
+                        <a:ea typeface="Calibri" charset="0"/>
+                        <a:cs typeface="Calibri" charset="0"/>
+                      </a:endParaRPr>
+                    </a:p>
+                  </a:txBody>
+                  <a:tcPr marL="50800" marR="50800" marT="50800" marB="50800" anchor="ctr">
+                    <a:lnL w="6350" cap="flat" cmpd="sng" algn="ctr">
+                      <a:solidFill>
+                        <a:srgbClr val="E2E2EC"/>
+                      </a:solidFill>
+                      <a:prstDash val="solid"/>
+                      <a:round/>
+                      <a:headEnd type="none" w="med" len="med"/>
+                      <a:tailEnd type="none" w="med" len="med"/>
+                    </a:lnL>
+                    <a:lnR w="6350" cap="flat" cmpd="sng" algn="ctr">
+                      <a:solidFill>
+                        <a:srgbClr val="E2E2EC"/>
+                      </a:solidFill>
+                      <a:prstDash val="solid"/>
+                      <a:round/>
+                      <a:headEnd type="none" w="med" len="med"/>
+                      <a:tailEnd type="none" w="med" len="med"/>
+                    </a:lnR>
+                    <a:lnT w="6350" cap="flat" cmpd="sng" algn="ctr">
+                      <a:solidFill>
+                        <a:srgbClr val="E2E2EC"/>
+                      </a:solidFill>
+                      <a:prstDash val="solid"/>
+                      <a:round/>
+                      <a:headEnd type="none" w="med" len="med"/>
+                      <a:tailEnd type="none" w="med" len="med"/>
+                    </a:lnT>
+                    <a:lnB w="6350" cap="flat" cmpd="sng" algn="ctr">
+                      <a:solidFill>
+                        <a:srgbClr val="E2E2EC"/>
+                      </a:solidFill>
+                      <a:prstDash val="solid"/>
+                      <a:round/>
+                      <a:headEnd type="none" w="med" len="med"/>
+                      <a:tailEnd type="none" w="med" len="med"/>
+                    </a:lnB>
+                    <a:solidFill>
+                      <a:srgbClr val="E9E9FE"/>
+                    </a:solidFill>
+                  </a:tcPr>
+                </a:tc>
+                <a:tc>
+                  <a:txBody>
+                    <a:bodyPr/>
+                    <a:lstStyle/>
+                    <a:p>
+                      <a:pPr indent="0" marL="0">
+                        <a:buNone/>
+                      </a:pPr>
+                      <a:r>
+                        <a:rPr lang="en-US" sz="900" dirty="0">
+                          <a:solidFill>
+                            <a:srgbClr val="5A5A72"/>
+                          </a:solidFill>
+                          <a:latin typeface="Calibri" pitchFamily="34" charset="0"/>
+                          <a:ea typeface="Calibri" pitchFamily="34" charset="-122"/>
+                          <a:cs typeface="Calibri" pitchFamily="34" charset="-120"/>
+                        </a:rPr>
+                        <a:t>Agent only sees the context for its immediate task</a:t>
+                      </a:r>
+                      <a:endParaRPr lang="en-US" sz="900" dirty="0">
+                        <a:latin typeface="Calibri" charset="0"/>
+                        <a:ea typeface="Calibri" charset="0"/>
+                        <a:cs typeface="Calibri" charset="0"/>
+                      </a:endParaRPr>
+                    </a:p>
+                  </a:txBody>
+                  <a:tcPr marL="50800" marR="50800" marT="50800" marB="50800" anchor="ctr">
+                    <a:lnL w="6350" cap="flat" cmpd="sng" algn="ctr">
+                      <a:solidFill>
+                        <a:srgbClr val="E2E2EC"/>
+                      </a:solidFill>
+                      <a:prstDash val="solid"/>
+                      <a:round/>
+                      <a:headEnd type="none" w="med" len="med"/>
+                      <a:tailEnd type="none" w="med" len="med"/>
+                    </a:lnL>
+                    <a:lnR w="6350" cap="flat" cmpd="sng" algn="ctr">
+                      <a:solidFill>
+                        <a:srgbClr val="E2E2EC"/>
+                      </a:solidFill>
+                      <a:prstDash val="solid"/>
+                      <a:round/>
+                      <a:headEnd type="none" w="med" len="med"/>
+                      <a:tailEnd type="none" w="med" len="med"/>
+                    </a:lnR>
+                    <a:lnT w="6350" cap="flat" cmpd="sng" algn="ctr">
+                      <a:solidFill>
+                        <a:srgbClr val="E2E2EC"/>
+                      </a:solidFill>
+                      <a:prstDash val="solid"/>
+                      <a:round/>
+                      <a:headEnd type="none" w="med" len="med"/>
+                      <a:tailEnd type="none" w="med" len="med"/>
+                    </a:lnT>
+                    <a:lnB w="6350" cap="flat" cmpd="sng" algn="ctr">
+                      <a:solidFill>
+                        <a:srgbClr val="E2E2EC"/>
+                      </a:solidFill>
+                      <a:prstDash val="solid"/>
+                      <a:round/>
+                      <a:headEnd type="none" w="med" len="med"/>
+                      <a:tailEnd type="none" w="med" len="med"/>
+                    </a:lnB>
+                    <a:solidFill>
+                      <a:srgbClr val="FFFFFF"/>
+                    </a:solidFill>
+                  </a:tcPr>
+                </a:tc>
+                <a:tc>
+                  <a:txBody>
+                    <a:bodyPr/>
+                    <a:lstStyle/>
+                    <a:p>
+                      <a:pPr indent="0" marL="0">
+                        <a:buNone/>
+                      </a:pPr>
+                      <a:r>
+                        <a:rPr lang="en-US" sz="900" dirty="0">
+                          <a:solidFill>
+                            <a:srgbClr val="5A5A72"/>
+                          </a:solidFill>
+                          <a:latin typeface="Calibri" pitchFamily="34" charset="0"/>
+                          <a:ea typeface="Calibri" pitchFamily="34" charset="-122"/>
+                          <a:cs typeface="Calibri" pitchFamily="34" charset="-120"/>
+                        </a:rPr>
+                        <a:t>Sequential workflow routing — each task receives only its declared prior-task context; input variables injected at run time</a:t>
+                      </a:r>
+                      <a:endParaRPr lang="en-US" sz="900" dirty="0">
+                        <a:latin typeface="Calibri" charset="0"/>
+                        <a:ea typeface="Calibri" charset="0"/>
+                        <a:cs typeface="Calibri" charset="0"/>
+                      </a:endParaRPr>
+                    </a:p>
+                  </a:txBody>
+                  <a:tcPr marL="50800" marR="50800" marT="50800" marB="50800" anchor="ctr">
+                    <a:lnL w="6350" cap="flat" cmpd="sng" algn="ctr">
+                      <a:solidFill>
+                        <a:srgbClr val="E2E2EC"/>
+                      </a:solidFill>
+                      <a:prstDash val="solid"/>
+                      <a:round/>
+                      <a:headEnd type="none" w="med" len="med"/>
+                      <a:tailEnd type="none" w="med" len="med"/>
+                    </a:lnL>
+                    <a:lnR w="6350" cap="flat" cmpd="sng" algn="ctr">
+                      <a:solidFill>
+                        <a:srgbClr val="E2E2EC"/>
+                      </a:solidFill>
+                      <a:prstDash val="solid"/>
+                      <a:round/>
+                      <a:headEnd type="none" w="med" len="med"/>
+                      <a:tailEnd type="none" w="med" len="med"/>
+                    </a:lnR>
+                    <a:lnT w="6350" cap="flat" cmpd="sng" algn="ctr">
+                      <a:solidFill>
+                        <a:srgbClr val="E2E2EC"/>
+                      </a:solidFill>
+                      <a:prstDash val="solid"/>
+                      <a:round/>
+                      <a:headEnd type="none" w="med" len="med"/>
+                      <a:tailEnd type="none" w="med" len="med"/>
+                    </a:lnT>
+                    <a:lnB w="6350" cap="flat" cmpd="sng" algn="ctr">
+                      <a:solidFill>
+                        <a:srgbClr val="E2E2EC"/>
+                      </a:solidFill>
+                      <a:prstDash val="solid"/>
+                      <a:round/>
+                      <a:headEnd type="none" w="med" len="med"/>
+                      <a:tailEnd type="none" w="med" len="med"/>
+                    </a:lnB>
+                    <a:solidFill>
+                      <a:srgbClr val="FFFFFF"/>
+                    </a:solidFill>
+                  </a:tcPr>
+                </a:tc>
+              </a:tr>
+              <a:tr h="731520">
+                <a:tc>
+                  <a:txBody>
+                    <a:bodyPr/>
+                    <a:lstStyle/>
+                    <a:p>
+                      <a:pPr indent="0" marL="0">
+                        <a:buNone/>
+                      </a:pPr>
+                      <a:r>
+                        <a:rPr lang="en-US" sz="900" b="1" dirty="0">
+                          <a:solidFill>
+                            <a:srgbClr val="4F4FF5"/>
+                          </a:solidFill>
+                          <a:latin typeface="Calibri" pitchFamily="34" charset="0"/>
+                          <a:ea typeface="Calibri" pitchFamily="34" charset="-122"/>
+                          <a:cs typeface="Calibri" pitchFamily="34" charset="-120"/>
+                        </a:rPr>
+                        <a:t>Agent Specialization &amp; Parallelism</a:t>
+                      </a:r>
+                      <a:endParaRPr lang="en-US" sz="900" dirty="0">
+                        <a:latin typeface="Calibri" charset="0"/>
+                        <a:ea typeface="Calibri" charset="0"/>
+                        <a:cs typeface="Calibri" charset="0"/>
+                      </a:endParaRPr>
+                    </a:p>
+                  </a:txBody>
+                  <a:tcPr marL="50800" marR="50800" marT="50800" marB="50800" anchor="ctr">
+                    <a:lnL w="6350" cap="flat" cmpd="sng" algn="ctr">
+                      <a:solidFill>
+                        <a:srgbClr val="E2E2EC"/>
+                      </a:solidFill>
+                      <a:prstDash val="solid"/>
+                      <a:round/>
+                      <a:headEnd type="none" w="med" len="med"/>
+                      <a:tailEnd type="none" w="med" len="med"/>
+                    </a:lnL>
+                    <a:lnR w="6350" cap="flat" cmpd="sng" algn="ctr">
+                      <a:solidFill>
+                        <a:srgbClr val="E2E2EC"/>
+                      </a:solidFill>
+                      <a:prstDash val="solid"/>
+                      <a:round/>
+                      <a:headEnd type="none" w="med" len="med"/>
+                      <a:tailEnd type="none" w="med" len="med"/>
+                    </a:lnR>
+                    <a:lnT w="6350" cap="flat" cmpd="sng" algn="ctr">
+                      <a:solidFill>
+                        <a:srgbClr val="E2E2EC"/>
+                      </a:solidFill>
+                      <a:prstDash val="solid"/>
+                      <a:round/>
+                      <a:headEnd type="none" w="med" len="med"/>
+                      <a:tailEnd type="none" w="med" len="med"/>
+                    </a:lnT>
+                    <a:lnB w="6350" cap="flat" cmpd="sng" algn="ctr">
+                      <a:solidFill>
+                        <a:srgbClr val="E2E2EC"/>
+                      </a:solidFill>
+                      <a:prstDash val="solid"/>
+                      <a:round/>
+                      <a:headEnd type="none" w="med" len="med"/>
+                      <a:tailEnd type="none" w="med" len="med"/>
+                    </a:lnB>
+                    <a:solidFill>
+                      <a:srgbClr val="E9E9FE"/>
+                    </a:solidFill>
+                  </a:tcPr>
+                </a:tc>
+                <a:tc>
+                  <a:txBody>
+                    <a:bodyPr/>
+                    <a:lstStyle/>
+                    <a:p>
+                      <a:pPr indent="0" marL="0">
+                        <a:buNone/>
+                      </a:pPr>
+                      <a:r>
+                        <a:rPr lang="en-US" sz="900" dirty="0">
+                          <a:solidFill>
+                            <a:srgbClr val="5A5A72"/>
+                          </a:solidFill>
+                          <a:latin typeface="Calibri" pitchFamily="34" charset="0"/>
+                          <a:ea typeface="Calibri" pitchFamily="34" charset="-122"/>
+                          <a:cs typeface="Calibri" pitchFamily="34" charset="-120"/>
+                        </a:rPr>
+                        <a:t>Focused agents with restricted toolsets outperform generalists</a:t>
+                      </a:r>
+                      <a:endParaRPr lang="en-US" sz="900" dirty="0">
+                        <a:latin typeface="Calibri" charset="0"/>
+                        <a:ea typeface="Calibri" charset="0"/>
+                        <a:cs typeface="Calibri" charset="0"/>
+                      </a:endParaRPr>
+                    </a:p>
+                  </a:txBody>
+                  <a:tcPr marL="50800" marR="50800" marT="50800" marB="50800" anchor="ctr">
+                    <a:lnL w="6350" cap="flat" cmpd="sng" algn="ctr">
+                      <a:solidFill>
+                        <a:srgbClr val="E2E2EC"/>
+                      </a:solidFill>
+                      <a:prstDash val="solid"/>
+                      <a:round/>
+                      <a:headEnd type="none" w="med" len="med"/>
+                      <a:tailEnd type="none" w="med" len="med"/>
+                    </a:lnL>
+                    <a:lnR w="6350" cap="flat" cmpd="sng" algn="ctr">
+                      <a:solidFill>
+                        <a:srgbClr val="E2E2EC"/>
+                      </a:solidFill>
+                      <a:prstDash val="solid"/>
+                      <a:round/>
+                      <a:headEnd type="none" w="med" len="med"/>
+                      <a:tailEnd type="none" w="med" len="med"/>
+                    </a:lnR>
+                    <a:lnT w="6350" cap="flat" cmpd="sng" algn="ctr">
+                      <a:solidFill>
+                        <a:srgbClr val="E2E2EC"/>
+                      </a:solidFill>
+                      <a:prstDash val="solid"/>
+                      <a:round/>
+                      <a:headEnd type="none" w="med" len="med"/>
+                      <a:tailEnd type="none" w="med" len="med"/>
+                    </a:lnT>
+                    <a:lnB w="6350" cap="flat" cmpd="sng" algn="ctr">
+                      <a:solidFill>
+                        <a:srgbClr val="E2E2EC"/>
+                      </a:solidFill>
+                      <a:prstDash val="solid"/>
+                      <a:round/>
+                      <a:headEnd type="none" w="med" len="med"/>
+                      <a:tailEnd type="none" w="med" len="med"/>
+                    </a:lnB>
+                    <a:solidFill>
+                      <a:srgbClr val="FFFFFF"/>
+                    </a:solidFill>
+                  </a:tcPr>
+                </a:tc>
+                <a:tc>
+                  <a:txBody>
+                    <a:bodyPr/>
+                    <a:lstStyle/>
+                    <a:p>
+                      <a:pPr indent="0" marL="0">
+                        <a:buNone/>
+                      </a:pPr>
+                      <a:r>
+                        <a:rPr lang="en-US" sz="900" dirty="0">
+                          <a:solidFill>
+                            <a:srgbClr val="5A5A72"/>
+                          </a:solidFill>
+                          <a:latin typeface="Calibri" pitchFamily="34" charset="0"/>
+                          <a:ea typeface="Calibri" pitchFamily="34" charset="-122"/>
+                          <a:cs typeface="Calibri" pitchFamily="34" charset="-120"/>
+                        </a:rPr>
+                        <a:t>Each agent gets its own Role, Goal, Backstory and an explicit scoped tool list — no god-mode access; Manager Agent pattern for hierarchical coordination</a:t>
+                      </a:r>
+                      <a:endParaRPr lang="en-US" sz="900" dirty="0">
+                        <a:latin typeface="Calibri" charset="0"/>
+                        <a:ea typeface="Calibri" charset="0"/>
+                        <a:cs typeface="Calibri" charset="0"/>
+                      </a:endParaRPr>
+                    </a:p>
+                  </a:txBody>
+                  <a:tcPr marL="50800" marR="50800" marT="50800" marB="50800" anchor="ctr">
+                    <a:lnL w="6350" cap="flat" cmpd="sng" algn="ctr">
+                      <a:solidFill>
+                        <a:srgbClr val="E2E2EC"/>
+                      </a:solidFill>
+                      <a:prstDash val="solid"/>
+                      <a:round/>
+                      <a:headEnd type="none" w="med" len="med"/>
+                      <a:tailEnd type="none" w="med" len="med"/>
+                    </a:lnL>
+                    <a:lnR w="6350" cap="flat" cmpd="sng" algn="ctr">
+                      <a:solidFill>
+                        <a:srgbClr val="E2E2EC"/>
+                      </a:solidFill>
+                      <a:prstDash val="solid"/>
+                      <a:round/>
+                      <a:headEnd type="none" w="med" len="med"/>
+                      <a:tailEnd type="none" w="med" len="med"/>
+                    </a:lnR>
+                    <a:lnT w="6350" cap="flat" cmpd="sng" algn="ctr">
+                      <a:solidFill>
+                        <a:srgbClr val="E2E2EC"/>
+                      </a:solidFill>
+                      <a:prstDash val="solid"/>
+                      <a:round/>
+                      <a:headEnd type="none" w="med" len="med"/>
+                      <a:tailEnd type="none" w="med" len="med"/>
+                    </a:lnT>
+                    <a:lnB w="6350" cap="flat" cmpd="sng" algn="ctr">
+                      <a:solidFill>
+                        <a:srgbClr val="E2E2EC"/>
+                      </a:solidFill>
+                      <a:prstDash val="solid"/>
+                      <a:round/>
+                      <a:headEnd type="none" w="med" len="med"/>
+                      <a:tailEnd type="none" w="med" len="med"/>
+                    </a:lnB>
+                    <a:solidFill>
+                      <a:srgbClr val="FFFFFF"/>
+                    </a:solidFill>
+                  </a:tcPr>
+                </a:tc>
+              </a:tr>
+              <a:tr h="731520">
+                <a:tc>
+                  <a:txBody>
+                    <a:bodyPr/>
+                    <a:lstStyle/>
+                    <a:p>
+                      <a:pPr indent="0" marL="0">
+                        <a:buNone/>
+                      </a:pPr>
+                      <a:r>
+                        <a:rPr lang="en-US" sz="900" b="1" dirty="0">
+                          <a:solidFill>
+                            <a:srgbClr val="4F4FF5"/>
+                          </a:solidFill>
+                          <a:latin typeface="Calibri" pitchFamily="34" charset="0"/>
+                          <a:ea typeface="Calibri" pitchFamily="34" charset="-122"/>
+                          <a:cs typeface="Calibri" pitchFamily="34" charset="-120"/>
+                        </a:rPr>
+                        <a:t>Persistent Memory &amp; State</a:t>
+                      </a:r>
+                      <a:endParaRPr lang="en-US" sz="900" dirty="0">
+                        <a:latin typeface="Calibri" charset="0"/>
+                        <a:ea typeface="Calibri" charset="0"/>
+                        <a:cs typeface="Calibri" charset="0"/>
+                      </a:endParaRPr>
+                    </a:p>
+                  </a:txBody>
+                  <a:tcPr marL="50800" marR="50800" marT="50800" marB="50800" anchor="ctr">
+                    <a:lnL w="6350" cap="flat" cmpd="sng" algn="ctr">
+                      <a:solidFill>
+                        <a:srgbClr val="E2E2EC"/>
+                      </a:solidFill>
+                      <a:prstDash val="solid"/>
+                      <a:round/>
+                      <a:headEnd type="none" w="med" len="med"/>
+                      <a:tailEnd type="none" w="med" len="med"/>
+                    </a:lnL>
+                    <a:lnR w="6350" cap="flat" cmpd="sng" algn="ctr">
+                      <a:solidFill>
+                        <a:srgbClr val="E2E2EC"/>
+                      </a:solidFill>
+                      <a:prstDash val="solid"/>
+                      <a:round/>
+                      <a:headEnd type="none" w="med" len="med"/>
+                      <a:tailEnd type="none" w="med" len="med"/>
+                    </a:lnR>
+                    <a:lnT w="6350" cap="flat" cmpd="sng" algn="ctr">
+                      <a:solidFill>
+                        <a:srgbClr val="E2E2EC"/>
+                      </a:solidFill>
+                      <a:prstDash val="solid"/>
+                      <a:round/>
+                      <a:headEnd type="none" w="med" len="med"/>
+                      <a:tailEnd type="none" w="med" len="med"/>
+                    </a:lnT>
+                    <a:lnB w="6350" cap="flat" cmpd="sng" algn="ctr">
+                      <a:solidFill>
+                        <a:srgbClr val="E2E2EC"/>
+                      </a:solidFill>
+                      <a:prstDash val="solid"/>
+                      <a:round/>
+                      <a:headEnd type="none" w="med" len="med"/>
+                      <a:tailEnd type="none" w="med" len="med"/>
+                    </a:lnB>
+                    <a:solidFill>
+                      <a:srgbClr val="E9E9FE"/>
+                    </a:solidFill>
+                  </a:tcPr>
+                </a:tc>
+                <a:tc>
+                  <a:txBody>
+                    <a:bodyPr/>
+                    <a:lstStyle/>
+                    <a:p>
+                      <a:pPr indent="0" marL="0">
+                        <a:buNone/>
+                      </a:pPr>
+                      <a:r>
+                        <a:rPr lang="en-US" sz="900" dirty="0">
+                          <a:solidFill>
+                            <a:srgbClr val="5A5A72"/>
+                          </a:solidFill>
+                          <a:latin typeface="Calibri" pitchFamily="34" charset="0"/>
+                          <a:ea typeface="Calibri" pitchFamily="34" charset="-122"/>
+                          <a:cs typeface="Calibri" pitchFamily="34" charset="-120"/>
+                        </a:rPr>
+                        <a:t>Memory lives outside the prompt window</a:t>
+                      </a:r>
+                      <a:endParaRPr lang="en-US" sz="900" dirty="0">
+                        <a:latin typeface="Calibri" charset="0"/>
+                        <a:ea typeface="Calibri" charset="0"/>
+                        <a:cs typeface="Calibri" charset="0"/>
+                      </a:endParaRPr>
+                    </a:p>
+                  </a:txBody>
+                  <a:tcPr marL="50800" marR="50800" marT="50800" marB="50800" anchor="ctr">
+                    <a:lnL w="6350" cap="flat" cmpd="sng" algn="ctr">
+                      <a:solidFill>
+                        <a:srgbClr val="E2E2EC"/>
+                      </a:solidFill>
+                      <a:prstDash val="solid"/>
+                      <a:round/>
+                      <a:headEnd type="none" w="med" len="med"/>
+                      <a:tailEnd type="none" w="med" len="med"/>
+                    </a:lnL>
+                    <a:lnR w="6350" cap="flat" cmpd="sng" algn="ctr">
+                      <a:solidFill>
+                        <a:srgbClr val="E2E2EC"/>
+                      </a:solidFill>
+                      <a:prstDash val="solid"/>
+                      <a:round/>
+                      <a:headEnd type="none" w="med" len="med"/>
+                      <a:tailEnd type="none" w="med" len="med"/>
+                    </a:lnR>
+                    <a:lnT w="6350" cap="flat" cmpd="sng" algn="ctr">
+                      <a:solidFill>
+                        <a:srgbClr val="E2E2EC"/>
+                      </a:solidFill>
+                      <a:prstDash val="solid"/>
+                      <a:round/>
+                      <a:headEnd type="none" w="med" len="med"/>
+                      <a:tailEnd type="none" w="med" len="med"/>
+                    </a:lnT>
+                    <a:lnB w="6350" cap="flat" cmpd="sng" algn="ctr">
+                      <a:solidFill>
+                        <a:srgbClr val="E2E2EC"/>
+                      </a:solidFill>
+                      <a:prstDash val="solid"/>
+                      <a:round/>
+                      <a:headEnd type="none" w="med" len="med"/>
+                      <a:tailEnd type="none" w="med" len="med"/>
+                    </a:lnB>
+                    <a:solidFill>
+                      <a:srgbClr val="FFFFFF"/>
+                    </a:solidFill>
+                  </a:tcPr>
+                </a:tc>
+                <a:tc>
+                  <a:txBody>
+                    <a:bodyPr/>
+                    <a:lstStyle/>
+                    <a:p>
+                      <a:pPr indent="0" marL="0">
+                        <a:buNone/>
+                      </a:pPr>
+                      <a:r>
+                        <a:rPr lang="en-US" sz="900" dirty="0">
+                          <a:solidFill>
+                            <a:srgbClr val="5A5A72"/>
+                          </a:solidFill>
+                          <a:latin typeface="Calibri" pitchFamily="34" charset="0"/>
+                          <a:ea typeface="Calibri" pitchFamily="34" charset="-122"/>
+                          <a:cs typeface="Calibri" pitchFamily="34" charset="-120"/>
+                        </a:rPr>
+                        <a:t>Artifact Files (shared virtual filesystem), workflow input variables, and progress.json-style state persist across tasks and sessions</a:t>
+                      </a:r>
+                      <a:endParaRPr lang="en-US" sz="900" dirty="0">
+                        <a:latin typeface="Calibri" charset="0"/>
+                        <a:ea typeface="Calibri" charset="0"/>
+                        <a:cs typeface="Calibri" charset="0"/>
+                      </a:endParaRPr>
+                    </a:p>
+                  </a:txBody>
+                  <a:tcPr marL="50800" marR="50800" marT="50800" marB="50800" anchor="ctr">
+                    <a:lnL w="6350" cap="flat" cmpd="sng" algn="ctr">
+                      <a:solidFill>
+                        <a:srgbClr val="E2E2EC"/>
+                      </a:solidFill>
+                      <a:prstDash val="solid"/>
+                      <a:round/>
+                      <a:headEnd type="none" w="med" len="med"/>
+                      <a:tailEnd type="none" w="med" len="med"/>
+                    </a:lnL>
+                    <a:lnR w="6350" cap="flat" cmpd="sng" algn="ctr">
+                      <a:solidFill>
+                        <a:srgbClr val="E2E2EC"/>
+                      </a:solidFill>
+                      <a:prstDash val="solid"/>
+                      <a:round/>
+                      <a:headEnd type="none" w="med" len="med"/>
+                      <a:tailEnd type="none" w="med" len="med"/>
+                    </a:lnR>
+                    <a:lnT w="6350" cap="flat" cmpd="sng" algn="ctr">
+                      <a:solidFill>
+                        <a:srgbClr val="E2E2EC"/>
+                      </a:solidFill>
+                      <a:prstDash val="solid"/>
+                      <a:round/>
+                      <a:headEnd type="none" w="med" len="med"/>
+                      <a:tailEnd type="none" w="med" len="med"/>
+                    </a:lnT>
+                    <a:lnB w="6350" cap="flat" cmpd="sng" algn="ctr">
+                      <a:solidFill>
+                        <a:srgbClr val="E2E2EC"/>
+                      </a:solidFill>
+                      <a:prstDash val="solid"/>
+                      <a:round/>
+                      <a:headEnd type="none" w="med" len="med"/>
+                      <a:tailEnd type="none" w="med" len="med"/>
+                    </a:lnB>
+                    <a:solidFill>
+                      <a:srgbClr val="FFFFFF"/>
+                    </a:solidFill>
+                  </a:tcPr>
+                </a:tc>
+              </a:tr>
+              <a:tr h="731520">
+                <a:tc>
+                  <a:txBody>
+                    <a:bodyPr/>
+                    <a:lstStyle/>
+                    <a:p>
+                      <a:pPr indent="0" marL="0">
+                        <a:buNone/>
+                      </a:pPr>
+                      <a:r>
+                        <a:rPr lang="en-US" sz="900" b="1" dirty="0">
+                          <a:solidFill>
+                            <a:srgbClr val="4F4FF5"/>
+                          </a:solidFill>
+                          <a:latin typeface="Calibri" pitchFamily="34" charset="0"/>
+                          <a:ea typeface="Calibri" pitchFamily="34" charset="-122"/>
+                          <a:cs typeface="Calibri" pitchFamily="34" charset="-120"/>
+                        </a:rPr>
+                        <a:t>Structured Execution &amp; Backpressure</a:t>
+                      </a:r>
+                      <a:endParaRPr lang="en-US" sz="900" dirty="0">
+                        <a:latin typeface="Calibri" charset="0"/>
+                        <a:ea typeface="Calibri" charset="0"/>
+                        <a:cs typeface="Calibri" charset="0"/>
+                      </a:endParaRPr>
+                    </a:p>
+                  </a:txBody>
+                  <a:tcPr marL="50800" marR="50800" marT="50800" marB="50800" anchor="ctr">
+                    <a:lnL w="6350" cap="flat" cmpd="sng" algn="ctr">
+                      <a:solidFill>
+                        <a:srgbClr val="E2E2EC"/>
+                      </a:solidFill>
+                      <a:prstDash val="solid"/>
+                      <a:round/>
+                      <a:headEnd type="none" w="med" len="med"/>
+                      <a:tailEnd type="none" w="med" len="med"/>
+                    </a:lnL>
+                    <a:lnR w="6350" cap="flat" cmpd="sng" algn="ctr">
+                      <a:solidFill>
+                        <a:srgbClr val="E2E2EC"/>
+                      </a:solidFill>
+                      <a:prstDash val="solid"/>
+                      <a:round/>
+                      <a:headEnd type="none" w="med" len="med"/>
+                      <a:tailEnd type="none" w="med" len="med"/>
+                    </a:lnR>
+                    <a:lnT w="6350" cap="flat" cmpd="sng" algn="ctr">
+                      <a:solidFill>
+                        <a:srgbClr val="E2E2EC"/>
+                      </a:solidFill>
+                      <a:prstDash val="solid"/>
+                      <a:round/>
+                      <a:headEnd type="none" w="med" len="med"/>
+                      <a:tailEnd type="none" w="med" len="med"/>
+                    </a:lnT>
+                    <a:lnB w="6350" cap="flat" cmpd="sng" algn="ctr">
+                      <a:solidFill>
+                        <a:srgbClr val="E2E2EC"/>
+                      </a:solidFill>
+                      <a:prstDash val="solid"/>
+                      <a:round/>
+                      <a:headEnd type="none" w="med" len="med"/>
+                      <a:tailEnd type="none" w="med" len="med"/>
+                    </a:lnB>
+                    <a:solidFill>
+                      <a:srgbClr val="E9E9FE"/>
+                    </a:solidFill>
+                  </a:tcPr>
+                </a:tc>
+                <a:tc>
+                  <a:txBody>
+                    <a:bodyPr/>
+                    <a:lstStyle/>
+                    <a:p>
+                      <a:pPr indent="0" marL="0">
+                        <a:buNone/>
+                      </a:pPr>
+                      <a:r>
+                        <a:rPr lang="en-US" sz="900" dirty="0">
+                          <a:solidFill>
+                            <a:srgbClr val="5A5A72"/>
+                          </a:solidFill>
+                          <a:latin typeface="Calibri" pitchFamily="34" charset="0"/>
+                          <a:ea typeface="Calibri" pitchFamily="34" charset="-122"/>
+                          <a:cs typeface="Calibri" pitchFamily="34" charset="-120"/>
+                        </a:rPr>
+                        <a:t>Mechanical constraints force correct behavior</a:t>
+                      </a:r>
+                      <a:endParaRPr lang="en-US" sz="900" dirty="0">
+                        <a:latin typeface="Calibri" charset="0"/>
+                        <a:ea typeface="Calibri" charset="0"/>
+                        <a:cs typeface="Calibri" charset="0"/>
+                      </a:endParaRPr>
+                    </a:p>
+                  </a:txBody>
+                  <a:tcPr marL="50800" marR="50800" marT="50800" marB="50800" anchor="ctr">
+                    <a:lnL w="6350" cap="flat" cmpd="sng" algn="ctr">
+                      <a:solidFill>
+                        <a:srgbClr val="E2E2EC"/>
+                      </a:solidFill>
+                      <a:prstDash val="solid"/>
+                      <a:round/>
+                      <a:headEnd type="none" w="med" len="med"/>
+                      <a:tailEnd type="none" w="med" len="med"/>
+                    </a:lnL>
+                    <a:lnR w="6350" cap="flat" cmpd="sng" algn="ctr">
+                      <a:solidFill>
+                        <a:srgbClr val="E2E2EC"/>
+                      </a:solidFill>
+                      <a:prstDash val="solid"/>
+                      <a:round/>
+                      <a:headEnd type="none" w="med" len="med"/>
+                      <a:tailEnd type="none" w="med" len="med"/>
+                    </a:lnR>
+                    <a:lnT w="6350" cap="flat" cmpd="sng" algn="ctr">
+                      <a:solidFill>
+                        <a:srgbClr val="E2E2EC"/>
+                      </a:solidFill>
+                      <a:prstDash val="solid"/>
+                      <a:round/>
+                      <a:headEnd type="none" w="med" len="med"/>
+                      <a:tailEnd type="none" w="med" len="med"/>
+                    </a:lnT>
+                    <a:lnB w="6350" cap="flat" cmpd="sng" algn="ctr">
+                      <a:solidFill>
+                        <a:srgbClr val="E2E2EC"/>
+                      </a:solidFill>
+                      <a:prstDash val="solid"/>
+                      <a:round/>
+                      <a:headEnd type="none" w="med" len="med"/>
+                      <a:tailEnd type="none" w="med" len="med"/>
+                    </a:lnB>
+                    <a:solidFill>
+                      <a:srgbClr val="FFFFFF"/>
+                    </a:solidFill>
+                  </a:tcPr>
+                </a:tc>
+                <a:tc>
+                  <a:txBody>
+                    <a:bodyPr/>
+                    <a:lstStyle/>
+                    <a:p>
+                      <a:pPr indent="0" marL="0">
+                        <a:buNone/>
+                      </a:pPr>
+                      <a:r>
+                        <a:rPr lang="en-US" sz="900" dirty="0">
+                          <a:solidFill>
+                            <a:srgbClr val="5A5A72"/>
+                          </a:solidFill>
+                          <a:latin typeface="Calibri" pitchFamily="34" charset="0"/>
+                          <a:ea typeface="Calibri" pitchFamily="34" charset="-122"/>
+                          <a:cs typeface="Calibri" pitchFamily="34" charset="-120"/>
+                        </a:rPr>
+                        <a:t>MCP guardrails, jailbreak tool, custom Python tools with typed parameters, CI/CD-ready deployment endpoints, and Phoenix observability for every run</a:t>
+                      </a:r>
+                      <a:endParaRPr lang="en-US" sz="900" dirty="0">
+                        <a:latin typeface="Calibri" charset="0"/>
+                        <a:ea typeface="Calibri" charset="0"/>
+                        <a:cs typeface="Calibri" charset="0"/>
+                      </a:endParaRPr>
+                    </a:p>
+                  </a:txBody>
+                  <a:tcPr marL="50800" marR="50800" marT="50800" marB="50800" anchor="ctr">
+                    <a:lnL w="6350" cap="flat" cmpd="sng" algn="ctr">
+                      <a:solidFill>
+                        <a:srgbClr val="E2E2EC"/>
+                      </a:solidFill>
+                      <a:prstDash val="solid"/>
+                      <a:round/>
+                      <a:headEnd type="none" w="med" len="med"/>
+                      <a:tailEnd type="none" w="med" len="med"/>
+                    </a:lnL>
+                    <a:lnR w="6350" cap="flat" cmpd="sng" algn="ctr">
+                      <a:solidFill>
+                        <a:srgbClr val="E2E2EC"/>
+                      </a:solidFill>
+                      <a:prstDash val="solid"/>
+                      <a:round/>
+                      <a:headEnd type="none" w="med" len="med"/>
+                      <a:tailEnd type="none" w="med" len="med"/>
+                    </a:lnR>
+                    <a:lnT w="6350" cap="flat" cmpd="sng" algn="ctr">
+                      <a:solidFill>
+                        <a:srgbClr val="E2E2EC"/>
+                      </a:solidFill>
+                      <a:prstDash val="solid"/>
+                      <a:round/>
+                      <a:headEnd type="none" w="med" len="med"/>
+                      <a:tailEnd type="none" w="med" len="med"/>
+                    </a:lnT>
+                    <a:lnB w="6350" cap="flat" cmpd="sng" algn="ctr">
+                      <a:solidFill>
+                        <a:srgbClr val="E2E2EC"/>
+                      </a:solidFill>
+                      <a:prstDash val="solid"/>
+                      <a:round/>
+                      <a:headEnd type="none" w="med" len="med"/>
+                      <a:tailEnd type="none" w="med" len="med"/>
+                    </a:lnB>
+                    <a:solidFill>
+                      <a:srgbClr val="FFFFFF"/>
+                    </a:solidFill>
+                  </a:tcPr>
+                </a:tc>
+              </a:tr>
+            </a:tbl>
+          </a:graphicData>
+        </a:graphic>
+      </p:graphicFrame>
+      <p:sp>
+        <p:nvSpPr>
+          <p:cNvPr id="7" name="Shape 4"/>
+          <p:cNvSpPr/>
+          <p:nvPr/>
+        </p:nvSpPr>
+        <p:spPr>
+          <a:xfrm>
+            <a:off x="566928" y="4526280"/>
+            <a:ext cx="8010144" cy="329184"/>
+          </a:xfrm>
+          <a:prstGeom prst="roundRect">
+            <a:avLst>
+              <a:gd name="adj" fmla="val 19444"/>
+            </a:avLst>
+          </a:prstGeom>
+          <a:solidFill>
+            <a:srgbClr val="15154A"/>
+          </a:solidFill>
+          <a:ln/>
+        </p:spPr>
+      </p:sp>
+      <p:sp>
+        <p:nvSpPr>
+          <p:cNvPr id="8" name="Text 5"/>
+          <p:cNvSpPr/>
+          <p:nvPr/>
+        </p:nvSpPr>
+        <p:spPr>
+          <a:xfrm>
+            <a:off x="749808" y="4526280"/>
+            <a:ext cx="7680960" cy="329184"/>
+          </a:xfrm>
+          <a:prstGeom prst="rect">
+            <a:avLst/>
+          </a:prstGeom>
+          <a:noFill/>
+          <a:ln/>
+        </p:spPr>
+        <p:txBody>
+          <a:bodyPr wrap="square" lIns="0" tIns="0" rIns="0" bIns="0" rtlCol="0" anchor="ctr"/>
+          <a:lstStyle/>
+          <a:p>
+            <a:pPr indent="0" marL="0">
+              <a:buNone/>
+            </a:pPr>
+            <a:r>
+              <a:rPr lang="en-US" sz="1050" b="1" dirty="0">
+                <a:solidFill>
+                  <a:srgbClr val="FFFFFF"/>
+                </a:solidFill>
+                <a:latin typeface="Calibri" pitchFamily="34" charset="0"/>
+                <a:ea typeface="Calibri" pitchFamily="34" charset="-122"/>
+                <a:cs typeface="Calibri" pitchFamily="34" charset="-120"/>
+              </a:rPr>
+              <a:t>Agent Studio is Cloudera's production harness for AI agents</a:t>
+            </a:r>
+            <a:pPr indent="0" marL="0">
+              <a:buNone/>
+            </a:pPr>
+            <a:r>
+              <a:rPr lang="en-US" sz="1050" dirty="0">
+                <a:solidFill>
+                  <a:srgbClr val="C9C9E6"/>
+                </a:solidFill>
+                <a:latin typeface="Calibri" pitchFamily="34" charset="0"/>
+                <a:ea typeface="Calibri" pitchFamily="34" charset="-122"/>
+                <a:cs typeface="Calibri" pitchFamily="34" charset="-120"/>
+              </a:rPr>
+              <a:t> — purpose-built to close the gap between the 2% deploying at scale and everyone else.</a:t>
+            </a:r>
+            <a:endParaRPr lang="en-US" sz="1050" dirty="0"/>
+          </a:p>
+        </p:txBody>
+      </p:sp>
+      <p:sp>
+        <p:nvSpPr>
+          <p:cNvPr id="9" name="Text 6"/>
+          <p:cNvSpPr/>
+          <p:nvPr/>
+        </p:nvSpPr>
+        <p:spPr>
+          <a:xfrm>
+            <a:off x="566928" y="4759452"/>
+            <a:ext cx="6858000" cy="256032"/>
+          </a:xfrm>
+          <a:prstGeom prst="rect">
+            <a:avLst/>
+          </a:prstGeom>
+          <a:noFill/>
+          <a:ln/>
+        </p:spPr>
+        <p:txBody>
+          <a:bodyPr wrap="square" lIns="0" tIns="0" rIns="0" bIns="0" rtlCol="0" anchor="ctr"/>
+          <a:lstStyle/>
+          <a:p>
+            <a:pPr indent="0" marL="0">
+              <a:buNone/>
+            </a:pPr>
+            <a:r>
+              <a:rPr lang="en-US" sz="800" dirty="0">
+                <a:solidFill>
+                  <a:srgbClr val="9A9AB4"/>
+                </a:solidFill>
+                <a:latin typeface="Calibri" pitchFamily="34" charset="0"/>
+                <a:ea typeface="Calibri" pitchFamily="34" charset="-122"/>
+                <a:cs typeface="Calibri" pitchFamily="34" charset="-120"/>
+              </a:rPr>
+              <a:t>©2026 Cloudera, Inc. All Rights Reserved.</a:t>
+            </a:r>
+            <a:endParaRPr lang="en-US" sz="800" dirty="0"/>
+          </a:p>
+        </p:txBody>
+      </p:sp>
+      <p:sp>
+        <p:nvSpPr>
+          <p:cNvPr id="10" name="Text 7"/>
+          <p:cNvSpPr/>
+          <p:nvPr/>
+        </p:nvSpPr>
+        <p:spPr>
+          <a:xfrm>
+            <a:off x="7955280" y="4759452"/>
+            <a:ext cx="640080" cy="256032"/>
+          </a:xfrm>
+          <a:prstGeom prst="rect">
+            <a:avLst/>
+          </a:prstGeom>
+          <a:noFill/>
+          <a:ln/>
+        </p:spPr>
+        <p:txBody>
+          <a:bodyPr wrap="square" lIns="0" tIns="0" rIns="0" bIns="0" rtlCol="0" anchor="ctr"/>
+          <a:lstStyle/>
+          <a:p>
+            <a:pPr algn="r" indent="0" marL="0">
+              <a:buNone/>
+            </a:pPr>
+            <a:r>
+              <a:rPr lang="en-US" sz="800" dirty="0">
+                <a:solidFill>
+                  <a:srgbClr val="9A9AB4"/>
+                </a:solidFill>
+                <a:latin typeface="Calibri" pitchFamily="34" charset="0"/>
+                <a:ea typeface="Calibri" pitchFamily="34" charset="-122"/>
+                <a:cs typeface="Calibri" pitchFamily="34" charset="-120"/>
+              </a:rPr>
+              <a:t>22 / 22</a:t>
             </a:r>
             <a:endParaRPr lang="en-US" sz="800" dirty="0"/>
           </a:p>
@@ -19065,7 +22733,7 @@
                 <a:ea typeface="Calibri" pitchFamily="34" charset="-122"/>
                 <a:cs typeface="Calibri" pitchFamily="34" charset="-120"/>
               </a:rPr>
-              <a:t>3 / 20</a:t>
+              <a:t>3 / 22</a:t>
             </a:r>
             <a:endParaRPr lang="en-US" sz="800" dirty="0"/>
           </a:p>
@@ -20342,7 +24010,7 @@
                 <a:ea typeface="Calibri" pitchFamily="34" charset="-122"/>
                 <a:cs typeface="Calibri" pitchFamily="34" charset="-120"/>
               </a:rPr>
-              <a:t>4 / 20</a:t>
+              <a:t>4 / 22</a:t>
             </a:r>
             <a:endParaRPr lang="en-US" sz="800" dirty="0"/>
           </a:p>
@@ -21368,7 +25036,7 @@
                 <a:ea typeface="Calibri" pitchFamily="34" charset="-122"/>
                 <a:cs typeface="Calibri" pitchFamily="34" charset="-120"/>
               </a:rPr>
-              <a:t>5 / 20</a:t>
+              <a:t>5 / 22</a:t>
             </a:r>
             <a:endParaRPr lang="en-US" sz="800" dirty="0"/>
           </a:p>
@@ -23528,7 +27196,7 @@
                 <a:ea typeface="Calibri" pitchFamily="34" charset="-122"/>
                 <a:cs typeface="Calibri" pitchFamily="34" charset="-120"/>
               </a:rPr>
-              <a:t>6 / 20</a:t>
+              <a:t>6 / 22</a:t>
             </a:r>
             <a:endParaRPr lang="en-US" sz="800" dirty="0"/>
           </a:p>
@@ -24922,7 +28590,7 @@
                 <a:ea typeface="Calibri" pitchFamily="34" charset="-122"/>
                 <a:cs typeface="Calibri" pitchFamily="34" charset="-120"/>
               </a:rPr>
-              <a:t>7 / 20</a:t>
+              <a:t>7 / 22</a:t>
             </a:r>
             <a:endParaRPr lang="en-US" sz="800" dirty="0"/>
           </a:p>
@@ -25895,7 +29563,7 @@
                 <a:ea typeface="Calibri" pitchFamily="34" charset="-122"/>
                 <a:cs typeface="Calibri" pitchFamily="34" charset="-120"/>
               </a:rPr>
-              <a:t>8 / 20</a:t>
+              <a:t>8 / 22</a:t>
             </a:r>
             <a:endParaRPr lang="en-US" sz="800" dirty="0"/>
           </a:p>
@@ -27911,7 +31579,7 @@
                 <a:ea typeface="Calibri" pitchFamily="34" charset="-122"/>
                 <a:cs typeface="Calibri" pitchFamily="34" charset="-120"/>
               </a:rPr>
-              <a:t>9 / 20</a:t>
+              <a:t>9 / 22</a:t>
             </a:r>
             <a:endParaRPr lang="en-US" sz="800" dirty="0"/>
           </a:p>

</xml_diff>

<commit_message>
feat(slides): add RAG positioning callouts to slide 11 (Memory Functions)
- Orange 'RAG source' badge on Factual (semantic) card
- Periwinkle 'RAG lands here' badge on Working card
- Second row in bottom strip: RAG pipeline flow
  Factual store (vector DB) → RAG retrieval → Working context (injected) → LLM response

Co-Authored-By: Claude <noreply@anthropic.com>
</commit_message>
<xml_diff>
--- a/Cloudera_AI_Landscape.pptx
+++ b/Cloudera_AI_Landscape.pptx
@@ -4955,12 +4955,134 @@
         </p:nvSpPr>
         <p:spPr>
           <a:xfrm>
-            <a:off x="566928" y="3383280"/>
-            <a:ext cx="8010144" cy="868680"/>
+            <a:off x="2322576" y="2907792"/>
+            <a:ext cx="694944" cy="201168"/>
           </a:xfrm>
           <a:prstGeom prst="roundRect">
             <a:avLst>
-              <a:gd name="adj" fmla="val 8421"/>
+              <a:gd name="adj" fmla="val 18182"/>
+            </a:avLst>
+          </a:prstGeom>
+          <a:solidFill>
+            <a:srgbClr val="EE5A29"/>
+          </a:solidFill>
+          <a:ln/>
+        </p:spPr>
+      </p:sp>
+      <p:sp>
+        <p:nvSpPr>
+          <p:cNvPr id="16" name="Text 14"/>
+          <p:cNvSpPr/>
+          <p:nvPr/>
+        </p:nvSpPr>
+        <p:spPr>
+          <a:xfrm>
+            <a:off x="2322576" y="2907792"/>
+            <a:ext cx="694944" cy="201168"/>
+          </a:xfrm>
+          <a:prstGeom prst="rect">
+            <a:avLst/>
+          </a:prstGeom>
+          <a:noFill/>
+          <a:ln/>
+        </p:spPr>
+        <p:txBody>
+          <a:bodyPr wrap="square" lIns="0" tIns="0" rIns="0" bIns="0" rtlCol="0" anchor="ctr"/>
+          <a:lstStyle/>
+          <a:p>
+            <a:pPr algn="ctr" indent="0" marL="0">
+              <a:buNone/>
+            </a:pPr>
+            <a:r>
+              <a:rPr lang="en-US" sz="750" b="1" dirty="0">
+                <a:solidFill>
+                  <a:srgbClr val="FFFFFF"/>
+                </a:solidFill>
+                <a:latin typeface="Plus Jakarta Sans" pitchFamily="34" charset="0"/>
+                <a:ea typeface="Plus Jakarta Sans" pitchFamily="34" charset="-122"/>
+                <a:cs typeface="Plus Jakarta Sans" pitchFamily="34" charset="-120"/>
+              </a:rPr>
+              <a:t>RAG source</a:t>
+            </a:r>
+            <a:endParaRPr lang="en-US" sz="750" dirty="0"/>
+          </a:p>
+        </p:txBody>
+      </p:sp>
+      <p:sp>
+        <p:nvSpPr>
+          <p:cNvPr id="17" name="Shape 15"/>
+          <p:cNvSpPr/>
+          <p:nvPr/>
+        </p:nvSpPr>
+        <p:spPr>
+          <a:xfrm>
+            <a:off x="7644384" y="2907792"/>
+            <a:ext cx="841248" cy="201168"/>
+          </a:xfrm>
+          <a:prstGeom prst="roundRect">
+            <a:avLst>
+              <a:gd name="adj" fmla="val 18182"/>
+            </a:avLst>
+          </a:prstGeom>
+          <a:solidFill>
+            <a:srgbClr val="4F4FF5"/>
+          </a:solidFill>
+          <a:ln/>
+        </p:spPr>
+      </p:sp>
+      <p:sp>
+        <p:nvSpPr>
+          <p:cNvPr id="18" name="Text 16"/>
+          <p:cNvSpPr/>
+          <p:nvPr/>
+        </p:nvSpPr>
+        <p:spPr>
+          <a:xfrm>
+            <a:off x="7644384" y="2907792"/>
+            <a:ext cx="841248" cy="201168"/>
+          </a:xfrm>
+          <a:prstGeom prst="rect">
+            <a:avLst/>
+          </a:prstGeom>
+          <a:noFill/>
+          <a:ln/>
+        </p:spPr>
+        <p:txBody>
+          <a:bodyPr wrap="square" lIns="0" tIns="0" rIns="0" bIns="0" rtlCol="0" anchor="ctr"/>
+          <a:lstStyle/>
+          <a:p>
+            <a:pPr algn="ctr" indent="0" marL="0">
+              <a:buNone/>
+            </a:pPr>
+            <a:r>
+              <a:rPr lang="en-US" sz="750" b="1" dirty="0">
+                <a:solidFill>
+                  <a:srgbClr val="FFFFFF"/>
+                </a:solidFill>
+                <a:latin typeface="Plus Jakarta Sans" pitchFamily="34" charset="0"/>
+                <a:ea typeface="Plus Jakarta Sans" pitchFamily="34" charset="-122"/>
+                <a:cs typeface="Plus Jakarta Sans" pitchFamily="34" charset="-120"/>
+              </a:rPr>
+              <a:t>RAG lands here</a:t>
+            </a:r>
+            <a:endParaRPr lang="en-US" sz="750" dirty="0"/>
+          </a:p>
+        </p:txBody>
+      </p:sp>
+      <p:sp>
+        <p:nvSpPr>
+          <p:cNvPr id="19" name="Shape 17"/>
+          <p:cNvSpPr/>
+          <p:nvPr/>
+        </p:nvSpPr>
+        <p:spPr>
+          <a:xfrm>
+            <a:off x="566928" y="3383280"/>
+            <a:ext cx="8010144" cy="1417320"/>
+          </a:xfrm>
+          <a:prstGeom prst="roundRect">
+            <a:avLst>
+              <a:gd name="adj" fmla="val 5161"/>
             </a:avLst>
           </a:prstGeom>
           <a:solidFill>
@@ -4971,14 +5093,14 @@
       </p:sp>
       <p:sp>
         <p:nvSpPr>
-          <p:cNvPr id="16" name="Text 14"/>
-          <p:cNvSpPr/>
-          <p:nvPr/>
-        </p:nvSpPr>
-        <p:spPr>
-          <a:xfrm>
-            <a:off x="749808" y="3493008"/>
-            <a:ext cx="7680960" cy="256032"/>
+          <p:cNvPr id="20" name="Text 18"/>
+          <p:cNvSpPr/>
+          <p:nvPr/>
+        </p:nvSpPr>
+        <p:spPr>
+          <a:xfrm>
+            <a:off x="749808" y="3465576"/>
+            <a:ext cx="7680960" cy="237744"/>
           </a:xfrm>
           <a:prstGeom prst="rect">
             <a:avLst/>
@@ -4994,7 +5116,7 @@
               <a:buNone/>
             </a:pPr>
             <a:r>
-              <a:rPr lang="en-US" sz="1100" b="1" dirty="0">
+              <a:rPr lang="en-US" sz="1050" b="1" dirty="0">
                 <a:solidFill>
                   <a:srgbClr val="15154A"/>
                 </a:solidFill>
@@ -5004,19 +5126,19 @@
               </a:rPr>
               <a:t>Experiential memory comes in flavors</a:t>
             </a:r>
-            <a:endParaRPr lang="en-US" sz="1100" dirty="0"/>
-          </a:p>
-        </p:txBody>
-      </p:sp>
-      <p:sp>
-        <p:nvSpPr>
-          <p:cNvPr id="17" name="Shape 15"/>
-          <p:cNvSpPr/>
-          <p:nvPr/>
-        </p:nvSpPr>
-        <p:spPr>
-          <a:xfrm>
-            <a:off x="749808" y="3840480"/>
+            <a:endParaRPr lang="en-US" sz="1050" dirty="0"/>
+          </a:p>
+        </p:txBody>
+      </p:sp>
+      <p:sp>
+        <p:nvSpPr>
+          <p:cNvPr id="21" name="Shape 19"/>
+          <p:cNvSpPr/>
+          <p:nvPr/>
+        </p:nvSpPr>
+        <p:spPr>
+          <a:xfrm>
+            <a:off x="749808" y="3749040"/>
             <a:ext cx="841248" cy="310896"/>
           </a:xfrm>
           <a:prstGeom prst="roundRect">
@@ -5037,13 +5159,13 @@
       </p:sp>
       <p:sp>
         <p:nvSpPr>
-          <p:cNvPr id="18" name="Text 16"/>
-          <p:cNvSpPr/>
-          <p:nvPr/>
-        </p:nvSpPr>
-        <p:spPr>
-          <a:xfrm>
-            <a:off x="749808" y="3840480"/>
+          <p:cNvPr id="22" name="Text 20"/>
+          <p:cNvSpPr/>
+          <p:nvPr/>
+        </p:nvSpPr>
+        <p:spPr>
+          <a:xfrm>
+            <a:off x="749808" y="3749040"/>
             <a:ext cx="841248" cy="310896"/>
           </a:xfrm>
           <a:prstGeom prst="rect">
@@ -5076,13 +5198,13 @@
       </p:sp>
       <p:sp>
         <p:nvSpPr>
-          <p:cNvPr id="19" name="Text 17"/>
-          <p:cNvSpPr/>
-          <p:nvPr/>
-        </p:nvSpPr>
-        <p:spPr>
-          <a:xfrm>
-            <a:off x="1591056" y="3840480"/>
+          <p:cNvPr id="23" name="Text 21"/>
+          <p:cNvSpPr/>
+          <p:nvPr/>
+        </p:nvSpPr>
+        <p:spPr>
+          <a:xfrm>
+            <a:off x="1591056" y="3749040"/>
             <a:ext cx="237744" cy="310896"/>
           </a:xfrm>
           <a:prstGeom prst="rect">
@@ -5115,13 +5237,13 @@
       </p:sp>
       <p:sp>
         <p:nvSpPr>
-          <p:cNvPr id="20" name="Shape 18"/>
-          <p:cNvSpPr/>
-          <p:nvPr/>
-        </p:nvSpPr>
-        <p:spPr>
-          <a:xfrm>
-            <a:off x="1828800" y="3840480"/>
+          <p:cNvPr id="24" name="Shape 22"/>
+          <p:cNvSpPr/>
+          <p:nvPr/>
+        </p:nvSpPr>
+        <p:spPr>
+          <a:xfrm>
+            <a:off x="1828800" y="3749040"/>
             <a:ext cx="907085" cy="310896"/>
           </a:xfrm>
           <a:prstGeom prst="roundRect">
@@ -5142,13 +5264,13 @@
       </p:sp>
       <p:sp>
         <p:nvSpPr>
-          <p:cNvPr id="21" name="Text 19"/>
-          <p:cNvSpPr/>
-          <p:nvPr/>
-        </p:nvSpPr>
-        <p:spPr>
-          <a:xfrm>
-            <a:off x="1828800" y="3840480"/>
+          <p:cNvPr id="25" name="Text 23"/>
+          <p:cNvSpPr/>
+          <p:nvPr/>
+        </p:nvSpPr>
+        <p:spPr>
+          <a:xfrm>
+            <a:off x="1828800" y="3749040"/>
             <a:ext cx="907085" cy="310896"/>
           </a:xfrm>
           <a:prstGeom prst="rect">
@@ -5181,13 +5303,13 @@
       </p:sp>
       <p:sp>
         <p:nvSpPr>
-          <p:cNvPr id="22" name="Text 20"/>
-          <p:cNvSpPr/>
-          <p:nvPr/>
-        </p:nvSpPr>
-        <p:spPr>
-          <a:xfrm>
-            <a:off x="2735885" y="3840480"/>
+          <p:cNvPr id="26" name="Text 24"/>
+          <p:cNvSpPr/>
+          <p:nvPr/>
+        </p:nvSpPr>
+        <p:spPr>
+          <a:xfrm>
+            <a:off x="2735885" y="3749040"/>
             <a:ext cx="237744" cy="310896"/>
           </a:xfrm>
           <a:prstGeom prst="rect">
@@ -5220,13 +5342,13 @@
       </p:sp>
       <p:sp>
         <p:nvSpPr>
-          <p:cNvPr id="23" name="Shape 21"/>
-          <p:cNvSpPr/>
-          <p:nvPr/>
-        </p:nvSpPr>
-        <p:spPr>
-          <a:xfrm>
-            <a:off x="2973629" y="3840480"/>
+          <p:cNvPr id="27" name="Shape 25"/>
+          <p:cNvSpPr/>
+          <p:nvPr/>
+        </p:nvSpPr>
+        <p:spPr>
+          <a:xfrm>
+            <a:off x="2973629" y="3749040"/>
             <a:ext cx="1104595" cy="310896"/>
           </a:xfrm>
           <a:prstGeom prst="roundRect">
@@ -5247,13 +5369,13 @@
       </p:sp>
       <p:sp>
         <p:nvSpPr>
-          <p:cNvPr id="24" name="Text 22"/>
-          <p:cNvSpPr/>
-          <p:nvPr/>
-        </p:nvSpPr>
-        <p:spPr>
-          <a:xfrm>
-            <a:off x="2973629" y="3840480"/>
+          <p:cNvPr id="28" name="Text 26"/>
+          <p:cNvSpPr/>
+          <p:nvPr/>
+        </p:nvSpPr>
+        <p:spPr>
+          <a:xfrm>
+            <a:off x="2973629" y="3749040"/>
             <a:ext cx="1104595" cy="310896"/>
           </a:xfrm>
           <a:prstGeom prst="rect">
@@ -5286,13 +5408,13 @@
       </p:sp>
       <p:sp>
         <p:nvSpPr>
-          <p:cNvPr id="25" name="Text 23"/>
-          <p:cNvSpPr/>
-          <p:nvPr/>
-        </p:nvSpPr>
-        <p:spPr>
-          <a:xfrm>
-            <a:off x="4078224" y="3840480"/>
+          <p:cNvPr id="29" name="Text 27"/>
+          <p:cNvSpPr/>
+          <p:nvPr/>
+        </p:nvSpPr>
+        <p:spPr>
+          <a:xfrm>
+            <a:off x="4078224" y="3749040"/>
             <a:ext cx="237744" cy="310896"/>
           </a:xfrm>
           <a:prstGeom prst="rect">
@@ -5325,13 +5447,13 @@
       </p:sp>
       <p:sp>
         <p:nvSpPr>
-          <p:cNvPr id="26" name="Shape 24"/>
-          <p:cNvSpPr/>
-          <p:nvPr/>
-        </p:nvSpPr>
-        <p:spPr>
-          <a:xfrm>
-            <a:off x="4315968" y="3840480"/>
+          <p:cNvPr id="30" name="Shape 28"/>
+          <p:cNvSpPr/>
+          <p:nvPr/>
+        </p:nvSpPr>
+        <p:spPr>
+          <a:xfrm>
+            <a:off x="4315968" y="3749040"/>
             <a:ext cx="777240" cy="310896"/>
           </a:xfrm>
           <a:prstGeom prst="roundRect">
@@ -5352,13 +5474,13 @@
       </p:sp>
       <p:sp>
         <p:nvSpPr>
-          <p:cNvPr id="27" name="Text 25"/>
-          <p:cNvSpPr/>
-          <p:nvPr/>
-        </p:nvSpPr>
-        <p:spPr>
-          <a:xfrm>
-            <a:off x="4315968" y="3840480"/>
+          <p:cNvPr id="31" name="Text 29"/>
+          <p:cNvSpPr/>
+          <p:nvPr/>
+        </p:nvSpPr>
+        <p:spPr>
+          <a:xfrm>
+            <a:off x="4315968" y="3749040"/>
             <a:ext cx="777240" cy="310896"/>
           </a:xfrm>
           <a:prstGeom prst="rect">
@@ -5391,7 +5513,447 @@
       </p:sp>
       <p:sp>
         <p:nvSpPr>
-          <p:cNvPr id="28" name="Text 26"/>
+          <p:cNvPr id="32" name="Shape 30"/>
+          <p:cNvSpPr/>
+          <p:nvPr/>
+        </p:nvSpPr>
+        <p:spPr>
+          <a:xfrm>
+            <a:off x="749808" y="4078224"/>
+            <a:ext cx="7644384" cy="12802"/>
+          </a:xfrm>
+          <a:prstGeom prst="rect">
+            <a:avLst/>
+          </a:prstGeom>
+          <a:solidFill>
+            <a:srgbClr val="E2E2EC"/>
+          </a:solidFill>
+          <a:ln/>
+        </p:spPr>
+      </p:sp>
+      <p:sp>
+        <p:nvSpPr>
+          <p:cNvPr id="33" name="Text 31"/>
+          <p:cNvSpPr/>
+          <p:nvPr/>
+        </p:nvSpPr>
+        <p:spPr>
+          <a:xfrm>
+            <a:off x="749808" y="4133088"/>
+            <a:ext cx="2743200" cy="219456"/>
+          </a:xfrm>
+          <a:prstGeom prst="rect">
+            <a:avLst/>
+          </a:prstGeom>
+          <a:noFill/>
+          <a:ln/>
+        </p:spPr>
+        <p:txBody>
+          <a:bodyPr wrap="square" lIns="0" tIns="0" rIns="0" bIns="0" rtlCol="0" anchor="ctr"/>
+          <a:lstStyle/>
+          <a:p>
+            <a:pPr indent="0" marL="0">
+              <a:buNone/>
+            </a:pPr>
+            <a:r>
+              <a:rPr lang="en-US" sz="1050" b="1" dirty="0">
+                <a:solidFill>
+                  <a:srgbClr val="EE5A29"/>
+                </a:solidFill>
+                <a:latin typeface="Plus Jakarta Sans" pitchFamily="34" charset="0"/>
+                <a:ea typeface="Plus Jakarta Sans" pitchFamily="34" charset="-122"/>
+                <a:cs typeface="Plus Jakarta Sans" pitchFamily="34" charset="-120"/>
+              </a:rPr>
+              <a:t>RAG pipeline</a:t>
+            </a:r>
+            <a:endParaRPr lang="en-US" sz="1050" dirty="0"/>
+          </a:p>
+        </p:txBody>
+      </p:sp>
+      <p:sp>
+        <p:nvSpPr>
+          <p:cNvPr id="34" name="Shape 32"/>
+          <p:cNvSpPr/>
+          <p:nvPr/>
+        </p:nvSpPr>
+        <p:spPr>
+          <a:xfrm>
+            <a:off x="749808" y="4370832"/>
+            <a:ext cx="1828800" cy="310896"/>
+          </a:xfrm>
+          <a:prstGeom prst="roundRect">
+            <a:avLst>
+              <a:gd name="adj" fmla="val 17647"/>
+            </a:avLst>
+          </a:prstGeom>
+          <a:solidFill>
+            <a:srgbClr val="FFFFFF"/>
+          </a:solidFill>
+          <a:ln w="15240">
+            <a:solidFill>
+              <a:srgbClr val="E2E2EC"/>
+            </a:solidFill>
+            <a:prstDash val="solid"/>
+          </a:ln>
+        </p:spPr>
+      </p:sp>
+      <p:sp>
+        <p:nvSpPr>
+          <p:cNvPr id="35" name="Text 33"/>
+          <p:cNvSpPr/>
+          <p:nvPr/>
+        </p:nvSpPr>
+        <p:spPr>
+          <a:xfrm>
+            <a:off x="749808" y="4370832"/>
+            <a:ext cx="1828800" cy="310896"/>
+          </a:xfrm>
+          <a:prstGeom prst="rect">
+            <a:avLst/>
+          </a:prstGeom>
+          <a:noFill/>
+          <a:ln/>
+        </p:spPr>
+        <p:txBody>
+          <a:bodyPr wrap="square" lIns="0" tIns="0" rIns="0" bIns="0" rtlCol="0" anchor="ctr"/>
+          <a:lstStyle/>
+          <a:p>
+            <a:pPr algn="ctr" indent="0" marL="0">
+              <a:buNone/>
+            </a:pPr>
+            <a:r>
+              <a:rPr lang="en-US" sz="900" b="1" dirty="0">
+                <a:solidFill>
+                  <a:srgbClr val="15154A"/>
+                </a:solidFill>
+                <a:latin typeface="Plus Jakarta Sans" pitchFamily="34" charset="0"/>
+                <a:ea typeface="Plus Jakarta Sans" pitchFamily="34" charset="-122"/>
+                <a:cs typeface="Plus Jakarta Sans" pitchFamily="34" charset="-120"/>
+              </a:rPr>
+              <a:t>Factual store (vector DB)</a:t>
+            </a:r>
+            <a:endParaRPr lang="en-US" sz="900" dirty="0"/>
+          </a:p>
+        </p:txBody>
+      </p:sp>
+      <p:sp>
+        <p:nvSpPr>
+          <p:cNvPr id="36" name="Text 34"/>
+          <p:cNvSpPr/>
+          <p:nvPr/>
+        </p:nvSpPr>
+        <p:spPr>
+          <a:xfrm>
+            <a:off x="2578608" y="4370832"/>
+            <a:ext cx="237744" cy="310896"/>
+          </a:xfrm>
+          <a:prstGeom prst="rect">
+            <a:avLst/>
+          </a:prstGeom>
+          <a:noFill/>
+          <a:ln/>
+        </p:spPr>
+        <p:txBody>
+          <a:bodyPr wrap="square" lIns="0" tIns="0" rIns="0" bIns="0" rtlCol="0" anchor="ctr"/>
+          <a:lstStyle/>
+          <a:p>
+            <a:pPr algn="ctr" indent="0" marL="0">
+              <a:buNone/>
+            </a:pPr>
+            <a:r>
+              <a:rPr lang="en-US" sz="1200" b="1" dirty="0">
+                <a:solidFill>
+                  <a:srgbClr val="EE5A29"/>
+                </a:solidFill>
+                <a:latin typeface="Plus Jakarta Sans" pitchFamily="34" charset="0"/>
+                <a:ea typeface="Plus Jakarta Sans" pitchFamily="34" charset="-122"/>
+                <a:cs typeface="Plus Jakarta Sans" pitchFamily="34" charset="-120"/>
+              </a:rPr>
+              <a:t>→</a:t>
+            </a:r>
+            <a:endParaRPr lang="en-US" sz="1200" dirty="0"/>
+          </a:p>
+        </p:txBody>
+      </p:sp>
+      <p:sp>
+        <p:nvSpPr>
+          <p:cNvPr id="37" name="Shape 35"/>
+          <p:cNvSpPr/>
+          <p:nvPr/>
+        </p:nvSpPr>
+        <p:spPr>
+          <a:xfrm>
+            <a:off x="2816352" y="4370832"/>
+            <a:ext cx="1038758" cy="310896"/>
+          </a:xfrm>
+          <a:prstGeom prst="roundRect">
+            <a:avLst>
+              <a:gd name="adj" fmla="val 17647"/>
+            </a:avLst>
+          </a:prstGeom>
+          <a:solidFill>
+            <a:srgbClr val="FFFFFF"/>
+          </a:solidFill>
+          <a:ln w="15240">
+            <a:solidFill>
+              <a:srgbClr val="E2E2EC"/>
+            </a:solidFill>
+            <a:prstDash val="solid"/>
+          </a:ln>
+        </p:spPr>
+      </p:sp>
+      <p:sp>
+        <p:nvSpPr>
+          <p:cNvPr id="38" name="Text 36"/>
+          <p:cNvSpPr/>
+          <p:nvPr/>
+        </p:nvSpPr>
+        <p:spPr>
+          <a:xfrm>
+            <a:off x="2816352" y="4370832"/>
+            <a:ext cx="1038758" cy="310896"/>
+          </a:xfrm>
+          <a:prstGeom prst="rect">
+            <a:avLst/>
+          </a:prstGeom>
+          <a:noFill/>
+          <a:ln/>
+        </p:spPr>
+        <p:txBody>
+          <a:bodyPr wrap="square" lIns="0" tIns="0" rIns="0" bIns="0" rtlCol="0" anchor="ctr"/>
+          <a:lstStyle/>
+          <a:p>
+            <a:pPr algn="ctr" indent="0" marL="0">
+              <a:buNone/>
+            </a:pPr>
+            <a:r>
+              <a:rPr lang="en-US" sz="900" b="1" dirty="0">
+                <a:solidFill>
+                  <a:srgbClr val="15154A"/>
+                </a:solidFill>
+                <a:latin typeface="Plus Jakarta Sans" pitchFamily="34" charset="0"/>
+                <a:ea typeface="Plus Jakarta Sans" pitchFamily="34" charset="-122"/>
+                <a:cs typeface="Plus Jakarta Sans" pitchFamily="34" charset="-120"/>
+              </a:rPr>
+              <a:t>RAG retrieval</a:t>
+            </a:r>
+            <a:endParaRPr lang="en-US" sz="900" dirty="0"/>
+          </a:p>
+        </p:txBody>
+      </p:sp>
+      <p:sp>
+        <p:nvSpPr>
+          <p:cNvPr id="39" name="Text 37"/>
+          <p:cNvSpPr/>
+          <p:nvPr/>
+        </p:nvSpPr>
+        <p:spPr>
+          <a:xfrm>
+            <a:off x="3855110" y="4370832"/>
+            <a:ext cx="237744" cy="310896"/>
+          </a:xfrm>
+          <a:prstGeom prst="rect">
+            <a:avLst/>
+          </a:prstGeom>
+          <a:noFill/>
+          <a:ln/>
+        </p:spPr>
+        <p:txBody>
+          <a:bodyPr wrap="square" lIns="0" tIns="0" rIns="0" bIns="0" rtlCol="0" anchor="ctr"/>
+          <a:lstStyle/>
+          <a:p>
+            <a:pPr algn="ctr" indent="0" marL="0">
+              <a:buNone/>
+            </a:pPr>
+            <a:r>
+              <a:rPr lang="en-US" sz="1200" b="1" dirty="0">
+                <a:solidFill>
+                  <a:srgbClr val="EE5A29"/>
+                </a:solidFill>
+                <a:latin typeface="Plus Jakarta Sans" pitchFamily="34" charset="0"/>
+                <a:ea typeface="Plus Jakarta Sans" pitchFamily="34" charset="-122"/>
+                <a:cs typeface="Plus Jakarta Sans" pitchFamily="34" charset="-120"/>
+              </a:rPr>
+              <a:t>→</a:t>
+            </a:r>
+            <a:endParaRPr lang="en-US" sz="1200" dirty="0"/>
+          </a:p>
+        </p:txBody>
+      </p:sp>
+      <p:sp>
+        <p:nvSpPr>
+          <p:cNvPr id="40" name="Shape 38"/>
+          <p:cNvSpPr/>
+          <p:nvPr/>
+        </p:nvSpPr>
+        <p:spPr>
+          <a:xfrm>
+            <a:off x="4092854" y="4370832"/>
+            <a:ext cx="1894637" cy="310896"/>
+          </a:xfrm>
+          <a:prstGeom prst="roundRect">
+            <a:avLst>
+              <a:gd name="adj" fmla="val 17647"/>
+            </a:avLst>
+          </a:prstGeom>
+          <a:solidFill>
+            <a:srgbClr val="FFFFFF"/>
+          </a:solidFill>
+          <a:ln w="15240">
+            <a:solidFill>
+              <a:srgbClr val="E2E2EC"/>
+            </a:solidFill>
+            <a:prstDash val="solid"/>
+          </a:ln>
+        </p:spPr>
+      </p:sp>
+      <p:sp>
+        <p:nvSpPr>
+          <p:cNvPr id="41" name="Text 39"/>
+          <p:cNvSpPr/>
+          <p:nvPr/>
+        </p:nvSpPr>
+        <p:spPr>
+          <a:xfrm>
+            <a:off x="4092854" y="4370832"/>
+            <a:ext cx="1894637" cy="310896"/>
+          </a:xfrm>
+          <a:prstGeom prst="rect">
+            <a:avLst/>
+          </a:prstGeom>
+          <a:noFill/>
+          <a:ln/>
+        </p:spPr>
+        <p:txBody>
+          <a:bodyPr wrap="square" lIns="0" tIns="0" rIns="0" bIns="0" rtlCol="0" anchor="ctr"/>
+          <a:lstStyle/>
+          <a:p>
+            <a:pPr algn="ctr" indent="0" marL="0">
+              <a:buNone/>
+            </a:pPr>
+            <a:r>
+              <a:rPr lang="en-US" sz="900" b="1" dirty="0">
+                <a:solidFill>
+                  <a:srgbClr val="15154A"/>
+                </a:solidFill>
+                <a:latin typeface="Plus Jakarta Sans" pitchFamily="34" charset="0"/>
+                <a:ea typeface="Plus Jakarta Sans" pitchFamily="34" charset="-122"/>
+                <a:cs typeface="Plus Jakarta Sans" pitchFamily="34" charset="-120"/>
+              </a:rPr>
+              <a:t>Working context (injected)</a:t>
+            </a:r>
+            <a:endParaRPr lang="en-US" sz="900" dirty="0"/>
+          </a:p>
+        </p:txBody>
+      </p:sp>
+      <p:sp>
+        <p:nvSpPr>
+          <p:cNvPr id="42" name="Text 40"/>
+          <p:cNvSpPr/>
+          <p:nvPr/>
+        </p:nvSpPr>
+        <p:spPr>
+          <a:xfrm>
+            <a:off x="5987491" y="4370832"/>
+            <a:ext cx="237744" cy="310896"/>
+          </a:xfrm>
+          <a:prstGeom prst="rect">
+            <a:avLst/>
+          </a:prstGeom>
+          <a:noFill/>
+          <a:ln/>
+        </p:spPr>
+        <p:txBody>
+          <a:bodyPr wrap="square" lIns="0" tIns="0" rIns="0" bIns="0" rtlCol="0" anchor="ctr"/>
+          <a:lstStyle/>
+          <a:p>
+            <a:pPr algn="ctr" indent="0" marL="0">
+              <a:buNone/>
+            </a:pPr>
+            <a:r>
+              <a:rPr lang="en-US" sz="1200" b="1" dirty="0">
+                <a:solidFill>
+                  <a:srgbClr val="EE5A29"/>
+                </a:solidFill>
+                <a:latin typeface="Plus Jakarta Sans" pitchFamily="34" charset="0"/>
+                <a:ea typeface="Plus Jakarta Sans" pitchFamily="34" charset="-122"/>
+                <a:cs typeface="Plus Jakarta Sans" pitchFamily="34" charset="-120"/>
+              </a:rPr>
+              <a:t>→</a:t>
+            </a:r>
+            <a:endParaRPr lang="en-US" sz="1200" dirty="0"/>
+          </a:p>
+        </p:txBody>
+      </p:sp>
+      <p:sp>
+        <p:nvSpPr>
+          <p:cNvPr id="43" name="Shape 41"/>
+          <p:cNvSpPr/>
+          <p:nvPr/>
+        </p:nvSpPr>
+        <p:spPr>
+          <a:xfrm>
+            <a:off x="6225235" y="4370832"/>
+            <a:ext cx="972922" cy="310896"/>
+          </a:xfrm>
+          <a:prstGeom prst="roundRect">
+            <a:avLst>
+              <a:gd name="adj" fmla="val 17647"/>
+            </a:avLst>
+          </a:prstGeom>
+          <a:solidFill>
+            <a:srgbClr val="FFFFFF"/>
+          </a:solidFill>
+          <a:ln w="15240">
+            <a:solidFill>
+              <a:srgbClr val="E2E2EC"/>
+            </a:solidFill>
+            <a:prstDash val="solid"/>
+          </a:ln>
+        </p:spPr>
+      </p:sp>
+      <p:sp>
+        <p:nvSpPr>
+          <p:cNvPr id="44" name="Text 42"/>
+          <p:cNvSpPr/>
+          <p:nvPr/>
+        </p:nvSpPr>
+        <p:spPr>
+          <a:xfrm>
+            <a:off x="6225235" y="4370832"/>
+            <a:ext cx="972922" cy="310896"/>
+          </a:xfrm>
+          <a:prstGeom prst="rect">
+            <a:avLst/>
+          </a:prstGeom>
+          <a:noFill/>
+          <a:ln/>
+        </p:spPr>
+        <p:txBody>
+          <a:bodyPr wrap="square" lIns="0" tIns="0" rIns="0" bIns="0" rtlCol="0" anchor="ctr"/>
+          <a:lstStyle/>
+          <a:p>
+            <a:pPr algn="ctr" indent="0" marL="0">
+              <a:buNone/>
+            </a:pPr>
+            <a:r>
+              <a:rPr lang="en-US" sz="900" b="1" dirty="0">
+                <a:solidFill>
+                  <a:srgbClr val="15154A"/>
+                </a:solidFill>
+                <a:latin typeface="Plus Jakarta Sans" pitchFamily="34" charset="0"/>
+                <a:ea typeface="Plus Jakarta Sans" pitchFamily="34" charset="-122"/>
+                <a:cs typeface="Plus Jakarta Sans" pitchFamily="34" charset="-120"/>
+              </a:rPr>
+              <a:t>LLM response</a:t>
+            </a:r>
+            <a:endParaRPr lang="en-US" sz="900" dirty="0"/>
+          </a:p>
+        </p:txBody>
+      </p:sp>
+      <p:sp>
+        <p:nvSpPr>
+          <p:cNvPr id="45" name="Text 43"/>
           <p:cNvSpPr/>
           <p:nvPr/>
         </p:nvSpPr>
@@ -5430,7 +5992,7 @@
       </p:sp>
       <p:sp>
         <p:nvSpPr>
-          <p:cNvPr id="29" name="Text 27"/>
+          <p:cNvPr id="46" name="Text 44"/>
           <p:cNvSpPr/>
           <p:nvPr/>
         </p:nvSpPr>

</xml_diff>